<commit_message>
feat: add Slide 4 for Solution 5.2 (LLM & Real-time API) in midterm presentation
</commit_message>
<xml_diff>
--- a/outputs/midterm_presentation.pptx
+++ b/outputs/midterm_presentation.pptx
@@ -12,6 +12,7 @@
     <p:sldId id="260" r:id="rId11"/>
     <p:sldId id="261" r:id="rId12"/>
     <p:sldId id="262" r:id="rId13"/>
+    <p:sldId id="263" r:id="rId14"/>
   </p:sldIdLst>
   <p:sldSz cx="12191695" cy="6858000" type="screen4x3"/>
   <p:notesSz cx="6858000" cy="9144000"/>
@@ -3931,7 +3932,7 @@
               </a:defRPr>
             </a:pPr>
             <a:r>
-              <a:t>3. Thông tin Bộ dữ liệu</a:t>
+              <a:t>3. Giải pháp đề xuất 5.2 (LLM &amp; Real-time API)</a:t>
             </a:r>
           </a:p>
           <a:p>
@@ -3947,7 +3948,7 @@
               </a:defRPr>
             </a:pPr>
             <a:r>
-              <a:t>Chi tiết về dữ liệu nguồn và dữ liệu làm giàu tiện ích</a:t>
+              <a:t>Kiến trúc hệ thống tư vấn thông minh tích hợp AI</a:t>
             </a:r>
           </a:p>
         </p:txBody>
@@ -4031,103 +4032,71 @@
               </a:defRPr>
             </a:pPr>
             <a:r>
-              <a:t>Dữ liệu Bất động sản nguồn</a:t>
-            </a:r>
-          </a:p>
-          <a:p>
-            <a:pPr>
-              <a:spcAft>
-                <a:spcPts val="800"/>
-              </a:spcAft>
-              <a:defRPr sz="1400">
-                <a:solidFill>
-                  <a:srgbClr val="F8FAFC"/>
-                </a:solidFill>
-                <a:latin typeface="Arial"/>
-              </a:defRPr>
-            </a:pPr>
-            <a:r>
-              <a:t>Bộ dữ liệu chính (HCMC Real Estate Data 2025):</a:t>
-            </a:r>
-          </a:p>
-          <a:p>
-            <a:pPr>
-              <a:spcAft>
-                <a:spcPts val="800"/>
-              </a:spcAft>
-              <a:defRPr sz="1400">
-                <a:solidFill>
-                  <a:srgbClr val="F8FAFC"/>
-                </a:solidFill>
-                <a:latin typeface="Arial"/>
-              </a:defRPr>
-            </a:pPr>
-            <a:r>
-              <a:t>  - Số mẫu ban đầu: 51,304 tin đăng tại TP.HCM.</a:t>
-            </a:r>
-          </a:p>
-          <a:p>
-            <a:pPr>
-              <a:spcAft>
-                <a:spcPts val="800"/>
-              </a:spcAft>
-              <a:defRPr sz="1400">
-                <a:solidFill>
-                  <a:srgbClr val="F8FAFC"/>
-                </a:solidFill>
-                <a:latin typeface="Arial"/>
-              </a:defRPr>
-            </a:pPr>
-            <a:r>
-              <a:t>  - Làm sạch &amp; Lọc subset (Gò Vấp): Lấy 37 mẫu Nhà riêng sạch.</a:t>
-            </a:r>
-          </a:p>
-          <a:p>
-            <a:pPr>
-              <a:spcAft>
-                <a:spcPts val="800"/>
-              </a:spcAft>
-              <a:defRPr sz="1400">
-                <a:solidFill>
-                  <a:srgbClr val="F8FAFC"/>
-                </a:solidFill>
-                <a:latin typeface="Arial"/>
-              </a:defRPr>
-            </a:pPr>
-            <a:r>
-              <a:t>  - Tiêu chí lọc sạch: Có tọa độ lat/lon, đầy đủ số phòng ngủ, phòng vệ sinh, giá trị hợp lý (500tr - 30 tỷ), diện tích 20 - 500m².</a:t>
-            </a:r>
-          </a:p>
-          <a:p>
-            <a:pPr>
-              <a:spcAft>
-                <a:spcPts val="800"/>
-              </a:spcAft>
-              <a:defRPr sz="1400">
-                <a:solidFill>
-                  <a:srgbClr val="F8FAFC"/>
-                </a:solidFill>
-                <a:latin typeface="Arial"/>
-              </a:defRPr>
-            </a:pPr>
-            <a:r>
-              <a:t>  - Phân bố giá trị trong Gò Vấp subset: 2.85 tỷ - 27.0 tỷ.</a:t>
-            </a:r>
-          </a:p>
-          <a:p>
-            <a:pPr>
-              <a:spcAft>
-                <a:spcPts val="800"/>
-              </a:spcAft>
-              <a:defRPr sz="1400">
-                <a:solidFill>
-                  <a:srgbClr val="F8FAFC"/>
-                </a:solidFill>
-                <a:latin typeface="Arial"/>
-              </a:defRPr>
-            </a:pPr>
-            <a:r>
-              <a:t>  - Diện tích subset: 26m² - 258m².</a:t>
+              <a:t>Luồng xử lý thông minh</a:t>
+            </a:r>
+          </a:p>
+          <a:p>
+            <a:pPr>
+              <a:spcAft>
+                <a:spcPts val="800"/>
+              </a:spcAft>
+              <a:defRPr sz="1400">
+                <a:solidFill>
+                  <a:srgbClr val="F8FAFC"/>
+                </a:solidFill>
+                <a:latin typeface="Arial"/>
+              </a:defRPr>
+            </a:pPr>
+            <a:r>
+              <a:t>1. Semantic Query Parsing: LLM đọc hiểu mong muốn tự do bằng tiếng Việt, phân tích ra các tiêu chí ẩn (ví dụ: 'yên tĩnh' -&gt; giảm điểm gần đường lớn).</a:t>
+            </a:r>
+          </a:p>
+          <a:p>
+            <a:pPr>
+              <a:spcAft>
+                <a:spcPts val="800"/>
+              </a:spcAft>
+              <a:defRPr sz="1400">
+                <a:solidFill>
+                  <a:srgbClr val="F8FAFC"/>
+                </a:solidFill>
+                <a:latin typeface="Arial"/>
+              </a:defRPr>
+            </a:pPr>
+            <a:r>
+              <a:t>2. Real-time POI Enrichment: Sử dụng Mapbox hoặc Google Places API để tự động truy xuất các tiện ích xung quanh tọa độ của từng BĐS thực tế.</a:t>
+            </a:r>
+          </a:p>
+          <a:p>
+            <a:pPr>
+              <a:spcAft>
+                <a:spcPts val="800"/>
+              </a:spcAft>
+              <a:defRPr sz="1400">
+                <a:solidFill>
+                  <a:srgbClr val="F8FAFC"/>
+                </a:solidFill>
+                <a:latin typeface="Arial"/>
+              </a:defRPr>
+            </a:pPr>
+            <a:r>
+              <a:t>3. Hybrid Scoring &amp; Re-ranking: Kết hợp điểm số khoảng cách POI và chấm điểm nội dung bằng LLM dựa trên thông tin mô tả chi tiết của BĐS (Description).</a:t>
+            </a:r>
+          </a:p>
+          <a:p>
+            <a:pPr>
+              <a:spcAft>
+                <a:spcPts val="800"/>
+              </a:spcAft>
+              <a:defRPr sz="1400">
+                <a:solidFill>
+                  <a:srgbClr val="F8FAFC"/>
+                </a:solidFill>
+                <a:latin typeface="Arial"/>
+              </a:defRPr>
+            </a:pPr>
+            <a:r>
+              <a:t>4. Tự động sinh báo cáo giải thích (LLM Explanation): Giải thích trực quan, tự nhiên và thuyết phục tại sao BĐS được chọn.</a:t>
             </a:r>
           </a:p>
         </p:txBody>
@@ -4211,103 +4180,71 @@
               </a:defRPr>
             </a:pPr>
             <a:r>
-              <a:t>Dữ liệu tiện ích bổ sung (POIs)</a:t>
-            </a:r>
-          </a:p>
-          <a:p>
-            <a:pPr>
-              <a:spcAft>
-                <a:spcPts val="800"/>
-              </a:spcAft>
-              <a:defRPr sz="1400">
-                <a:solidFill>
-                  <a:srgbClr val="F8FAFC"/>
-                </a:solidFill>
-                <a:latin typeface="Arial"/>
-              </a:defRPr>
-            </a:pPr>
-            <a:r>
-              <a:t>Bổ sung tọa độ địa lý thực tế của các tiện ích tại Quận Gò Vấp:</a:t>
-            </a:r>
-          </a:p>
-          <a:p>
-            <a:pPr>
-              <a:spcAft>
-                <a:spcPts val="800"/>
-              </a:spcAft>
-              <a:defRPr sz="1400">
-                <a:solidFill>
-                  <a:srgbClr val="F8FAFC"/>
-                </a:solidFill>
-                <a:latin typeface="Arial"/>
-              </a:defRPr>
-            </a:pPr>
-            <a:r>
-              <a:t>  - 8 Trường học nổi tiếng (Nguyễn Du, Lương Thế Vinh, Trần Hưng Đạo...)</a:t>
-            </a:r>
-          </a:p>
-          <a:p>
-            <a:pPr>
-              <a:spcAft>
-                <a:spcPts val="800"/>
-              </a:spcAft>
-              <a:defRPr sz="1400">
-                <a:solidFill>
-                  <a:srgbClr val="F8FAFC"/>
-                </a:solidFill>
-                <a:latin typeface="Arial"/>
-              </a:defRPr>
-            </a:pPr>
-            <a:r>
-              <a:t>  - 4 Công viên lớn (Làng Hoa, Gia Định, phường 12...)</a:t>
-            </a:r>
-          </a:p>
-          <a:p>
-            <a:pPr>
-              <a:spcAft>
-                <a:spcPts val="800"/>
-              </a:spcAft>
-              <a:defRPr sz="1400">
-                <a:solidFill>
-                  <a:srgbClr val="F8FAFC"/>
-                </a:solidFill>
-                <a:latin typeface="Arial"/>
-              </a:defRPr>
-            </a:pPr>
-            <a:r>
-              <a:t>  - 3 Bệnh viện chính (Bệnh viện Gò Vấp, Bệnh viện 175...)</a:t>
-            </a:r>
-          </a:p>
-          <a:p>
-            <a:pPr>
-              <a:spcAft>
-                <a:spcPts val="800"/>
-              </a:spcAft>
-              <a:defRPr sz="1400">
-                <a:solidFill>
-                  <a:srgbClr val="F8FAFC"/>
-                </a:solidFill>
-                <a:latin typeface="Arial"/>
-              </a:defRPr>
-            </a:pPr>
-            <a:r>
-              <a:t>  - 5 Siêu thị tiện ích (Emart Gò Vấp, Coopmart Quang Trung, VinMart...)</a:t>
-            </a:r>
-          </a:p>
-          <a:p>
-            <a:pPr>
-              <a:spcAft>
-                <a:spcPts val="800"/>
-              </a:spcAft>
-              <a:defRPr sz="1400">
-                <a:solidFill>
-                  <a:srgbClr val="F8FAFC"/>
-                </a:solidFill>
-                <a:latin typeface="Arial"/>
-              </a:defRPr>
-            </a:pPr>
-            <a:r>
-              <a:t>  - 4 Trục đường lớn di chuyển (Quang Trung, Nguyễn Oanh, Phạm Văn Đồng...)</a:t>
+              <a:t>Ưu điểm vượt trội so với 5.1</a:t>
+            </a:r>
+          </a:p>
+          <a:p>
+            <a:pPr>
+              <a:spcAft>
+                <a:spcPts val="800"/>
+              </a:spcAft>
+              <a:defRPr sz="1400">
+                <a:solidFill>
+                  <a:srgbClr val="F8FAFC"/>
+                </a:solidFill>
+                <a:latin typeface="Arial"/>
+              </a:defRPr>
+            </a:pPr>
+            <a:r>
+              <a:t>🔹 Trải nghiệm người dùng cao: Không cần nhập các form khảo sát phức tạp, chỉ cần trò chuyện tự do.</a:t>
+            </a:r>
+          </a:p>
+          <a:p>
+            <a:pPr>
+              <a:spcAft>
+                <a:spcPts val="800"/>
+              </a:spcAft>
+              <a:defRPr sz="1400">
+                <a:solidFill>
+                  <a:srgbClr val="F8FAFC"/>
+                </a:solidFill>
+                <a:latin typeface="Arial"/>
+              </a:defRPr>
+            </a:pPr>
+            <a:r>
+              <a:t>🔹 Độ chính xác tiện ích tuyệt đối: Lấy POI theo thời gian thực tại bất kỳ vị trí nào, không bị giới hạn bởi database tĩnh.</a:t>
+            </a:r>
+          </a:p>
+          <a:p>
+            <a:pPr>
+              <a:spcAft>
+                <a:spcPts val="800"/>
+              </a:spcAft>
+              <a:defRPr sz="1400">
+                <a:solidFill>
+                  <a:srgbClr val="F8FAFC"/>
+                </a:solidFill>
+                <a:latin typeface="Arial"/>
+              </a:defRPr>
+            </a:pPr>
+            <a:r>
+              <a:t>🔹 Đánh giá BĐS sâu sắc hơn: Đọc hiểu được thông tin phi cấu trúc (ví dụ: hẻm xe hơi, nội thất cao cấp, nở hậu) từ Description tin đăng.</a:t>
+            </a:r>
+          </a:p>
+          <a:p>
+            <a:pPr>
+              <a:spcAft>
+                <a:spcPts val="800"/>
+              </a:spcAft>
+              <a:defRPr sz="1400">
+                <a:solidFill>
+                  <a:srgbClr val="F8FAFC"/>
+                </a:solidFill>
+                <a:latin typeface="Arial"/>
+              </a:defRPr>
+            </a:pPr>
+            <a:r>
+              <a:t>🔹 Cá nhân hóa tối đa: Lý giải lý do đề xuất riêng biệt cho từng người dùng bằng văn phong tiếng Việt tự nhiên.</a:t>
             </a:r>
           </a:p>
         </p:txBody>
@@ -4369,7 +4306,445 @@
               </a:defRPr>
             </a:pPr>
             <a:r>
-              <a:t>4. Cách đánh giá Hệ thống tư vấn (DSS Evaluation)</a:t>
+              <a:t>4. Thông tin Bộ dữ liệu</a:t>
+            </a:r>
+          </a:p>
+          <a:p>
+            <a:pPr>
+              <a:spcBef>
+                <a:spcPts val="800"/>
+              </a:spcBef>
+              <a:defRPr sz="1600">
+                <a:solidFill>
+                  <a:srgbClr val="94A3B8"/>
+                </a:solidFill>
+                <a:latin typeface="Arial"/>
+              </a:defRPr>
+            </a:pPr>
+            <a:r>
+              <a:t>Chi tiết về dữ liệu nguồn và dữ liệu làm giàu tiện ích</a:t>
+            </a:r>
+          </a:p>
+        </p:txBody>
+      </p:sp>
+      <p:sp>
+        <p:nvSpPr>
+          <p:cNvPr id="3" name="Rectangle 2"/>
+          <p:cNvSpPr/>
+          <p:nvPr/>
+        </p:nvSpPr>
+        <p:spPr>
+          <a:xfrm>
+            <a:off x="731520" y="1828800"/>
+            <a:ext cx="5120640" cy="4114800"/>
+          </a:xfrm>
+          <a:prstGeom prst="rect">
+            <a:avLst/>
+          </a:prstGeom>
+          <a:solidFill>
+            <a:srgbClr val="1E293B"/>
+          </a:solidFill>
+          <a:ln w="19050">
+            <a:solidFill>
+              <a:srgbClr val="475569"/>
+            </a:solidFill>
+          </a:ln>
+        </p:spPr>
+        <p:style>
+          <a:lnRef idx="1">
+            <a:schemeClr val="accent1"/>
+          </a:lnRef>
+          <a:fillRef idx="3">
+            <a:schemeClr val="accent1"/>
+          </a:fillRef>
+          <a:effectRef idx="2">
+            <a:schemeClr val="accent1"/>
+          </a:effectRef>
+          <a:fontRef idx="minor">
+            <a:schemeClr val="lt1"/>
+          </a:fontRef>
+        </p:style>
+        <p:txBody>
+          <a:bodyPr rtlCol="0" anchor="ctr"/>
+          <a:lstStyle/>
+          <a:p>
+            <a:pPr algn="ctr"/>
+          </a:p>
+        </p:txBody>
+      </p:sp>
+      <p:sp>
+        <p:nvSpPr>
+          <p:cNvPr id="4" name="TextBox 3"/>
+          <p:cNvSpPr txBox="1"/>
+          <p:nvPr/>
+        </p:nvSpPr>
+        <p:spPr>
+          <a:xfrm>
+            <a:off x="960120" y="2057400"/>
+            <a:ext cx="4663440" cy="3657600"/>
+          </a:xfrm>
+          <a:prstGeom prst="rect">
+            <a:avLst/>
+          </a:prstGeom>
+          <a:noFill/>
+        </p:spPr>
+        <p:txBody>
+          <a:bodyPr wrap="square" lIns="0" tIns="0" rIns="0" bIns="0">
+            <a:spAutoFit/>
+          </a:bodyPr>
+          <a:lstStyle/>
+          <a:p>
+            <a:pPr>
+              <a:spcAft>
+                <a:spcPts val="1200"/>
+              </a:spcAft>
+              <a:defRPr sz="2000" b="1">
+                <a:solidFill>
+                  <a:srgbClr val="38BDF8"/>
+                </a:solidFill>
+                <a:latin typeface="Arial"/>
+              </a:defRPr>
+            </a:pPr>
+            <a:r>
+              <a:t>Dữ liệu Bất động sản nguồn</a:t>
+            </a:r>
+          </a:p>
+          <a:p>
+            <a:pPr>
+              <a:spcAft>
+                <a:spcPts val="800"/>
+              </a:spcAft>
+              <a:defRPr sz="1400">
+                <a:solidFill>
+                  <a:srgbClr val="F8FAFC"/>
+                </a:solidFill>
+                <a:latin typeface="Arial"/>
+              </a:defRPr>
+            </a:pPr>
+            <a:r>
+              <a:t>Bộ dữ liệu chính (HCMC Real Estate Data 2025):</a:t>
+            </a:r>
+          </a:p>
+          <a:p>
+            <a:pPr>
+              <a:spcAft>
+                <a:spcPts val="800"/>
+              </a:spcAft>
+              <a:defRPr sz="1400">
+                <a:solidFill>
+                  <a:srgbClr val="F8FAFC"/>
+                </a:solidFill>
+                <a:latin typeface="Arial"/>
+              </a:defRPr>
+            </a:pPr>
+            <a:r>
+              <a:t>  - Số mẫu ban đầu: 51,304 tin đăng tại TP.HCM.</a:t>
+            </a:r>
+          </a:p>
+          <a:p>
+            <a:pPr>
+              <a:spcAft>
+                <a:spcPts val="800"/>
+              </a:spcAft>
+              <a:defRPr sz="1400">
+                <a:solidFill>
+                  <a:srgbClr val="F8FAFC"/>
+                </a:solidFill>
+                <a:latin typeface="Arial"/>
+              </a:defRPr>
+            </a:pPr>
+            <a:r>
+              <a:t>  - Làm sạch &amp; Lọc subset (Gò Vấp): Lấy 37 mẫu Nhà riêng sạch.</a:t>
+            </a:r>
+          </a:p>
+          <a:p>
+            <a:pPr>
+              <a:spcAft>
+                <a:spcPts val="800"/>
+              </a:spcAft>
+              <a:defRPr sz="1400">
+                <a:solidFill>
+                  <a:srgbClr val="F8FAFC"/>
+                </a:solidFill>
+                <a:latin typeface="Arial"/>
+              </a:defRPr>
+            </a:pPr>
+            <a:r>
+              <a:t>  - Tiêu chí lọc sạch: Có tọa độ lat/lon, đầy đủ số phòng ngủ, phòng vệ sinh, giá trị hợp lý (500tr - 30 tỷ), diện tích 20 - 500m².</a:t>
+            </a:r>
+          </a:p>
+          <a:p>
+            <a:pPr>
+              <a:spcAft>
+                <a:spcPts val="800"/>
+              </a:spcAft>
+              <a:defRPr sz="1400">
+                <a:solidFill>
+                  <a:srgbClr val="F8FAFC"/>
+                </a:solidFill>
+                <a:latin typeface="Arial"/>
+              </a:defRPr>
+            </a:pPr>
+            <a:r>
+              <a:t>  - Phân bố giá trị trong Gò Vấp subset: 2.85 tỷ - 27.0 tỷ.</a:t>
+            </a:r>
+          </a:p>
+          <a:p>
+            <a:pPr>
+              <a:spcAft>
+                <a:spcPts val="800"/>
+              </a:spcAft>
+              <a:defRPr sz="1400">
+                <a:solidFill>
+                  <a:srgbClr val="F8FAFC"/>
+                </a:solidFill>
+                <a:latin typeface="Arial"/>
+              </a:defRPr>
+            </a:pPr>
+            <a:r>
+              <a:t>  - Diện tích subset: 26m² - 258m².</a:t>
+            </a:r>
+          </a:p>
+        </p:txBody>
+      </p:sp>
+      <p:sp>
+        <p:nvSpPr>
+          <p:cNvPr id="5" name="Rectangle 4"/>
+          <p:cNvSpPr/>
+          <p:nvPr/>
+        </p:nvSpPr>
+        <p:spPr>
+          <a:xfrm>
+            <a:off x="6217920" y="1828800"/>
+            <a:ext cx="5212080" cy="4114800"/>
+          </a:xfrm>
+          <a:prstGeom prst="rect">
+            <a:avLst/>
+          </a:prstGeom>
+          <a:solidFill>
+            <a:srgbClr val="1E293B"/>
+          </a:solidFill>
+          <a:ln w="19050">
+            <a:solidFill>
+              <a:srgbClr val="475569"/>
+            </a:solidFill>
+          </a:ln>
+        </p:spPr>
+        <p:style>
+          <a:lnRef idx="1">
+            <a:schemeClr val="accent1"/>
+          </a:lnRef>
+          <a:fillRef idx="3">
+            <a:schemeClr val="accent1"/>
+          </a:fillRef>
+          <a:effectRef idx="2">
+            <a:schemeClr val="accent1"/>
+          </a:effectRef>
+          <a:fontRef idx="minor">
+            <a:schemeClr val="lt1"/>
+          </a:fontRef>
+        </p:style>
+        <p:txBody>
+          <a:bodyPr rtlCol="0" anchor="ctr"/>
+          <a:lstStyle/>
+          <a:p>
+            <a:pPr algn="ctr"/>
+          </a:p>
+        </p:txBody>
+      </p:sp>
+      <p:sp>
+        <p:nvSpPr>
+          <p:cNvPr id="6" name="TextBox 5"/>
+          <p:cNvSpPr txBox="1"/>
+          <p:nvPr/>
+        </p:nvSpPr>
+        <p:spPr>
+          <a:xfrm>
+            <a:off x="6446520" y="2057400"/>
+            <a:ext cx="4754880" cy="3657600"/>
+          </a:xfrm>
+          <a:prstGeom prst="rect">
+            <a:avLst/>
+          </a:prstGeom>
+          <a:noFill/>
+        </p:spPr>
+        <p:txBody>
+          <a:bodyPr wrap="square" lIns="0" tIns="0" rIns="0" bIns="0">
+            <a:spAutoFit/>
+          </a:bodyPr>
+          <a:lstStyle/>
+          <a:p>
+            <a:pPr>
+              <a:spcAft>
+                <a:spcPts val="1200"/>
+              </a:spcAft>
+              <a:defRPr sz="2000" b="1">
+                <a:solidFill>
+                  <a:srgbClr val="FBBF24"/>
+                </a:solidFill>
+                <a:latin typeface="Arial"/>
+              </a:defRPr>
+            </a:pPr>
+            <a:r>
+              <a:t>Dữ liệu tiện ích bổ sung (POIs)</a:t>
+            </a:r>
+          </a:p>
+          <a:p>
+            <a:pPr>
+              <a:spcAft>
+                <a:spcPts val="800"/>
+              </a:spcAft>
+              <a:defRPr sz="1400">
+                <a:solidFill>
+                  <a:srgbClr val="F8FAFC"/>
+                </a:solidFill>
+                <a:latin typeface="Arial"/>
+              </a:defRPr>
+            </a:pPr>
+            <a:r>
+              <a:t>Bổ sung tọa độ địa lý thực tế của các tiện ích tại Quận Gò Vấp:</a:t>
+            </a:r>
+          </a:p>
+          <a:p>
+            <a:pPr>
+              <a:spcAft>
+                <a:spcPts val="800"/>
+              </a:spcAft>
+              <a:defRPr sz="1400">
+                <a:solidFill>
+                  <a:srgbClr val="F8FAFC"/>
+                </a:solidFill>
+                <a:latin typeface="Arial"/>
+              </a:defRPr>
+            </a:pPr>
+            <a:r>
+              <a:t>  - 8 Trường học nổi tiếng (Nguyễn Du, Lương Thế Vinh, Trần Hưng Đạo...)</a:t>
+            </a:r>
+          </a:p>
+          <a:p>
+            <a:pPr>
+              <a:spcAft>
+                <a:spcPts val="800"/>
+              </a:spcAft>
+              <a:defRPr sz="1400">
+                <a:solidFill>
+                  <a:srgbClr val="F8FAFC"/>
+                </a:solidFill>
+                <a:latin typeface="Arial"/>
+              </a:defRPr>
+            </a:pPr>
+            <a:r>
+              <a:t>  - 4 Công viên lớn (Làng Hoa, Gia Định, phường 12...)</a:t>
+            </a:r>
+          </a:p>
+          <a:p>
+            <a:pPr>
+              <a:spcAft>
+                <a:spcPts val="800"/>
+              </a:spcAft>
+              <a:defRPr sz="1400">
+                <a:solidFill>
+                  <a:srgbClr val="F8FAFC"/>
+                </a:solidFill>
+                <a:latin typeface="Arial"/>
+              </a:defRPr>
+            </a:pPr>
+            <a:r>
+              <a:t>  - 3 Bệnh viện chính (Bệnh viện Gò Vấp, Bệnh viện 175...)</a:t>
+            </a:r>
+          </a:p>
+          <a:p>
+            <a:pPr>
+              <a:spcAft>
+                <a:spcPts val="800"/>
+              </a:spcAft>
+              <a:defRPr sz="1400">
+                <a:solidFill>
+                  <a:srgbClr val="F8FAFC"/>
+                </a:solidFill>
+                <a:latin typeface="Arial"/>
+              </a:defRPr>
+            </a:pPr>
+            <a:r>
+              <a:t>  - 5 Siêu thị tiện ích (Emart Gò Vấp, Coopmart Quang Trung, VinMart...)</a:t>
+            </a:r>
+          </a:p>
+          <a:p>
+            <a:pPr>
+              <a:spcAft>
+                <a:spcPts val="800"/>
+              </a:spcAft>
+              <a:defRPr sz="1400">
+                <a:solidFill>
+                  <a:srgbClr val="F8FAFC"/>
+                </a:solidFill>
+                <a:latin typeface="Arial"/>
+              </a:defRPr>
+            </a:pPr>
+            <a:r>
+              <a:t>  - 4 Trục đường lớn di chuyển (Quang Trung, Nguyễn Oanh, Phạm Văn Đồng...)</a:t>
+            </a:r>
+          </a:p>
+        </p:txBody>
+      </p:sp>
+    </p:spTree>
+  </p:cSld>
+  <p:clrMapOvr>
+    <a:masterClrMapping/>
+  </p:clrMapOvr>
+</p:sld>
+</file>
+
+<file path=ppt/slides/slide6.xml><?xml version="1.0" encoding="utf-8"?>
+<p:sld xmlns:a="http://schemas.openxmlformats.org/drawingml/2006/main" xmlns:p="http://schemas.openxmlformats.org/presentationml/2006/main" xmlns:r="http://schemas.openxmlformats.org/officeDocument/2006/relationships">
+  <p:cSld>
+    <p:bg>
+      <p:bgPr>
+        <a:solidFill>
+          <a:srgbClr val="0F172A"/>
+        </a:solidFill>
+        <a:effectLst/>
+      </p:bgPr>
+    </p:bg>
+    <p:spTree>
+      <p:nvGrpSpPr>
+        <p:cNvPr id="1" name=""/>
+        <p:cNvGrpSpPr/>
+        <p:nvPr/>
+      </p:nvGrpSpPr>
+      <p:grpSpPr/>
+      <p:sp>
+        <p:nvSpPr>
+          <p:cNvPr id="2" name="TextBox 1"/>
+          <p:cNvSpPr txBox="1"/>
+          <p:nvPr/>
+        </p:nvSpPr>
+        <p:spPr>
+          <a:xfrm>
+            <a:off x="731520" y="457200"/>
+            <a:ext cx="10698480" cy="1097280"/>
+          </a:xfrm>
+          <a:prstGeom prst="rect">
+            <a:avLst/>
+          </a:prstGeom>
+          <a:noFill/>
+        </p:spPr>
+        <p:txBody>
+          <a:bodyPr wrap="square" lIns="0" tIns="0" rIns="0" bIns="0">
+            <a:spAutoFit/>
+          </a:bodyPr>
+          <a:lstStyle/>
+          <a:p>
+            <a:pPr>
+              <a:defRPr sz="3600" b="1">
+                <a:solidFill>
+                  <a:srgbClr val="38BDF8"/>
+                </a:solidFill>
+                <a:latin typeface="Arial"/>
+              </a:defRPr>
+            </a:pPr>
+            <a:r>
+              <a:t>5. Cách đánh giá Hệ thống tư vấn (DSS Evaluation)</a:t>
             </a:r>
           </a:p>
           <a:p>
@@ -4562,7 +4937,7 @@
 </p:sld>
 </file>
 
-<file path=ppt/slides/slide6.xml><?xml version="1.0" encoding="utf-8"?>
+<file path=ppt/slides/slide7.xml><?xml version="1.0" encoding="utf-8"?>
 <p:sld xmlns:a="http://schemas.openxmlformats.org/drawingml/2006/main" xmlns:p="http://schemas.openxmlformats.org/presentationml/2006/main" xmlns:r="http://schemas.openxmlformats.org/officeDocument/2006/relationships">
   <p:cSld>
     <p:bg>
@@ -4611,7 +4986,7 @@
               </a:defRPr>
             </a:pPr>
             <a:r>
-              <a:t>5. Kết quả Sơ khởi - Persona 1 &amp; 2</a:t>
+              <a:t>6. Kết quả Sơ khởi - Persona 1 &amp; 2</a:t>
             </a:r>
           </a:p>
           <a:p>
@@ -5000,7 +5375,7 @@
 </p:sld>
 </file>
 
-<file path=ppt/slides/slide7.xml><?xml version="1.0" encoding="utf-8"?>
+<file path=ppt/slides/slide8.xml><?xml version="1.0" encoding="utf-8"?>
 <p:sld xmlns:a="http://schemas.openxmlformats.org/drawingml/2006/main" xmlns:p="http://schemas.openxmlformats.org/presentationml/2006/main" xmlns:r="http://schemas.openxmlformats.org/officeDocument/2006/relationships">
   <p:cSld>
     <p:bg>
@@ -5049,7 +5424,7 @@
               </a:defRPr>
             </a:pPr>
             <a:r>
-              <a:t>6. Kết quả Sơ khởi - Persona 3 &amp; Kế hoạch</a:t>
+              <a:t>7. Kết quả Sơ khởi - Persona 3 &amp; Kế hoạch</a:t>
             </a:r>
           </a:p>
           <a:p>
@@ -5329,7 +5704,7 @@
               </a:defRPr>
             </a:pPr>
             <a:r>
-              <a:t>Kế hoạch phát triển tiếp theo</a:t>
+              <a:t>Kế hoạch phát triển tiếp theo (Pipeline 5.2)</a:t>
             </a:r>
           </a:p>
           <a:p>

</xml_diff>

<commit_message>
style: change midterm presentation theme to light layout
</commit_message>
<xml_diff>
--- a/outputs/midterm_presentation.pptx
+++ b/outputs/midterm_presentation.pptx
@@ -3091,7 +3091,7 @@
     <p:bg>
       <p:bgPr>
         <a:solidFill>
-          <a:srgbClr val="0F172A"/>
+          <a:srgbClr val="F8FAFC"/>
         </a:solidFill>
         <a:effectLst/>
       </p:bgPr>
@@ -3131,7 +3131,7 @@
               </a:spcAft>
               <a:defRPr sz="3800" b="1">
                 <a:solidFill>
-                  <a:srgbClr val="F8FAFC"/>
+                  <a:srgbClr val="0F172A"/>
                 </a:solidFill>
                 <a:latin typeface="Arial"/>
               </a:defRPr>
@@ -3151,7 +3151,7 @@
               </a:spcAft>
               <a:defRPr sz="2000">
                 <a:solidFill>
-                  <a:srgbClr val="38BDF8"/>
+                  <a:srgbClr val="1D4ED8"/>
                 </a:solidFill>
                 <a:latin typeface="Arial"/>
               </a:defRPr>
@@ -3164,7 +3164,7 @@
             <a:pPr>
               <a:defRPr sz="1400">
                 <a:solidFill>
-                  <a:srgbClr val="94A3B8"/>
+                  <a:srgbClr val="64748B"/>
                 </a:solidFill>
                 <a:latin typeface="Arial"/>
               </a:defRPr>
@@ -3193,7 +3193,7 @@
     <p:bg>
       <p:bgPr>
         <a:solidFill>
-          <a:srgbClr val="0F172A"/>
+          <a:srgbClr val="F8FAFC"/>
         </a:solidFill>
         <a:effectLst/>
       </p:bgPr>
@@ -3230,7 +3230,7 @@
             <a:pPr>
               <a:defRPr sz="3600" b="1">
                 <a:solidFill>
-                  <a:srgbClr val="38BDF8"/>
+                  <a:srgbClr val="1D4ED8"/>
                 </a:solidFill>
                 <a:latin typeface="Arial"/>
               </a:defRPr>
@@ -3246,7 +3246,7 @@
               </a:spcBef>
               <a:defRPr sz="1600">
                 <a:solidFill>
-                  <a:srgbClr val="94A3B8"/>
+                  <a:srgbClr val="64748B"/>
                 </a:solidFill>
                 <a:latin typeface="Arial"/>
               </a:defRPr>
@@ -3272,11 +3272,11 @@
             <a:avLst/>
           </a:prstGeom>
           <a:solidFill>
-            <a:srgbClr val="1E293B"/>
+            <a:srgbClr val="FFFFFF"/>
           </a:solidFill>
           <a:ln w="19050">
             <a:solidFill>
-              <a:srgbClr val="475569"/>
+              <a:srgbClr val="CBD5E1"/>
             </a:solidFill>
           </a:ln>
         </p:spPr>
@@ -3330,7 +3330,7 @@
               </a:spcAft>
               <a:defRPr sz="2000" b="1">
                 <a:solidFill>
-                  <a:srgbClr val="38BDF8"/>
+                  <a:srgbClr val="1D4ED8"/>
                 </a:solidFill>
                 <a:latin typeface="Arial"/>
               </a:defRPr>
@@ -3346,7 +3346,7 @@
               </a:spcAft>
               <a:defRPr sz="1400">
                 <a:solidFill>
-                  <a:srgbClr val="F8FAFC"/>
+                  <a:srgbClr val="0F172A"/>
                 </a:solidFill>
                 <a:latin typeface="Arial"/>
               </a:defRPr>
@@ -3362,7 +3362,7 @@
               </a:spcAft>
               <a:defRPr sz="1400">
                 <a:solidFill>
-                  <a:srgbClr val="F8FAFC"/>
+                  <a:srgbClr val="0F172A"/>
                 </a:solidFill>
                 <a:latin typeface="Arial"/>
               </a:defRPr>
@@ -3378,7 +3378,7 @@
               </a:spcAft>
               <a:defRPr sz="1400">
                 <a:solidFill>
-                  <a:srgbClr val="F8FAFC"/>
+                  <a:srgbClr val="0F172A"/>
                 </a:solidFill>
                 <a:latin typeface="Arial"/>
               </a:defRPr>
@@ -3394,7 +3394,7 @@
               </a:spcAft>
               <a:defRPr sz="1400">
                 <a:solidFill>
-                  <a:srgbClr val="F8FAFC"/>
+                  <a:srgbClr val="0F172A"/>
                 </a:solidFill>
                 <a:latin typeface="Arial"/>
               </a:defRPr>
@@ -3410,7 +3410,7 @@
               </a:spcAft>
               <a:defRPr sz="1400">
                 <a:solidFill>
-                  <a:srgbClr val="F8FAFC"/>
+                  <a:srgbClr val="0F172A"/>
                 </a:solidFill>
                 <a:latin typeface="Arial"/>
               </a:defRPr>
@@ -3426,7 +3426,7 @@
               </a:spcAft>
               <a:defRPr sz="1400">
                 <a:solidFill>
-                  <a:srgbClr val="F8FAFC"/>
+                  <a:srgbClr val="0F172A"/>
                 </a:solidFill>
                 <a:latin typeface="Arial"/>
               </a:defRPr>
@@ -3452,11 +3452,11 @@
             <a:avLst/>
           </a:prstGeom>
           <a:solidFill>
-            <a:srgbClr val="1E293B"/>
+            <a:srgbClr val="FFFFFF"/>
           </a:solidFill>
           <a:ln w="19050">
             <a:solidFill>
-              <a:srgbClr val="475569"/>
+              <a:srgbClr val="CBD5E1"/>
             </a:solidFill>
           </a:ln>
         </p:spPr>
@@ -3510,7 +3510,7 @@
               </a:spcAft>
               <a:defRPr sz="2000" b="1">
                 <a:solidFill>
-                  <a:srgbClr val="FBBF24"/>
+                  <a:srgbClr val="B45309"/>
                 </a:solidFill>
                 <a:latin typeface="Arial"/>
               </a:defRPr>
@@ -3526,7 +3526,7 @@
               </a:spcAft>
               <a:defRPr sz="1400">
                 <a:solidFill>
-                  <a:srgbClr val="F8FAFC"/>
+                  <a:srgbClr val="0F172A"/>
                 </a:solidFill>
                 <a:latin typeface="Arial"/>
               </a:defRPr>
@@ -3542,7 +3542,7 @@
               </a:spcAft>
               <a:defRPr sz="1400">
                 <a:solidFill>
-                  <a:srgbClr val="F8FAFC"/>
+                  <a:srgbClr val="0F172A"/>
                 </a:solidFill>
                 <a:latin typeface="Arial"/>
               </a:defRPr>
@@ -3558,7 +3558,7 @@
               </a:spcAft>
               <a:defRPr sz="1400">
                 <a:solidFill>
-                  <a:srgbClr val="F8FAFC"/>
+                  <a:srgbClr val="0F172A"/>
                 </a:solidFill>
                 <a:latin typeface="Arial"/>
               </a:defRPr>
@@ -3574,7 +3574,7 @@
               </a:spcAft>
               <a:defRPr sz="1400">
                 <a:solidFill>
-                  <a:srgbClr val="F8FAFC"/>
+                  <a:srgbClr val="0F172A"/>
                 </a:solidFill>
                 <a:latin typeface="Arial"/>
               </a:defRPr>
@@ -3590,7 +3590,7 @@
               </a:spcAft>
               <a:defRPr sz="1400">
                 <a:solidFill>
-                  <a:srgbClr val="F8FAFC"/>
+                  <a:srgbClr val="0F172A"/>
                 </a:solidFill>
                 <a:latin typeface="Arial"/>
               </a:defRPr>
@@ -3606,7 +3606,7 @@
               </a:spcAft>
               <a:defRPr sz="1400">
                 <a:solidFill>
-                  <a:srgbClr val="F8FAFC"/>
+                  <a:srgbClr val="0F172A"/>
                 </a:solidFill>
                 <a:latin typeface="Arial"/>
               </a:defRPr>
@@ -3631,7 +3631,7 @@
     <p:bg>
       <p:bgPr>
         <a:solidFill>
-          <a:srgbClr val="0F172A"/>
+          <a:srgbClr val="F8FAFC"/>
         </a:solidFill>
         <a:effectLst/>
       </p:bgPr>
@@ -3668,7 +3668,7 @@
             <a:pPr>
               <a:defRPr sz="3600" b="1">
                 <a:solidFill>
-                  <a:srgbClr val="38BDF8"/>
+                  <a:srgbClr val="1D4ED8"/>
                 </a:solidFill>
                 <a:latin typeface="Arial"/>
               </a:defRPr>
@@ -3684,7 +3684,7 @@
               </a:spcBef>
               <a:defRPr sz="1600">
                 <a:solidFill>
-                  <a:srgbClr val="94A3B8"/>
+                  <a:srgbClr val="64748B"/>
                 </a:solidFill>
                 <a:latin typeface="Arial"/>
               </a:defRPr>
@@ -3710,11 +3710,11 @@
             <a:avLst/>
           </a:prstGeom>
           <a:solidFill>
-            <a:srgbClr val="1E293B"/>
+            <a:srgbClr val="FFFFFF"/>
           </a:solidFill>
           <a:ln w="19050">
             <a:solidFill>
-              <a:srgbClr val="475569"/>
+              <a:srgbClr val="CBD5E1"/>
             </a:solidFill>
           </a:ln>
         </p:spPr>
@@ -3768,7 +3768,7 @@
               </a:spcAft>
               <a:defRPr sz="2000" b="1">
                 <a:solidFill>
-                  <a:srgbClr val="38BDF8"/>
+                  <a:srgbClr val="1D4ED8"/>
                 </a:solidFill>
                 <a:latin typeface="Arial"/>
               </a:defRPr>
@@ -3784,7 +3784,7 @@
               </a:spcAft>
               <a:defRPr sz="1400">
                 <a:solidFill>
-                  <a:srgbClr val="F8FAFC"/>
+                  <a:srgbClr val="0F172A"/>
                 </a:solidFill>
                 <a:latin typeface="Arial"/>
               </a:defRPr>
@@ -3800,7 +3800,7 @@
               </a:spcAft>
               <a:defRPr sz="1400">
                 <a:solidFill>
-                  <a:srgbClr val="F8FAFC"/>
+                  <a:srgbClr val="0F172A"/>
                 </a:solidFill>
                 <a:latin typeface="Arial"/>
               </a:defRPr>
@@ -3816,7 +3816,7 @@
               </a:spcAft>
               <a:defRPr sz="1400">
                 <a:solidFill>
-                  <a:srgbClr val="F8FAFC"/>
+                  <a:srgbClr val="0F172A"/>
                 </a:solidFill>
                 <a:latin typeface="Arial"/>
               </a:defRPr>
@@ -3832,7 +3832,7 @@
               </a:spcAft>
               <a:defRPr sz="1400">
                 <a:solidFill>
-                  <a:srgbClr val="F8FAFC"/>
+                  <a:srgbClr val="0F172A"/>
                 </a:solidFill>
                 <a:latin typeface="Arial"/>
               </a:defRPr>
@@ -3848,7 +3848,7 @@
               </a:spcAft>
               <a:defRPr sz="1400">
                 <a:solidFill>
-                  <a:srgbClr val="F8FAFC"/>
+                  <a:srgbClr val="0F172A"/>
                 </a:solidFill>
                 <a:latin typeface="Arial"/>
               </a:defRPr>
@@ -3864,7 +3864,7 @@
               </a:spcAft>
               <a:defRPr sz="1400">
                 <a:solidFill>
-                  <a:srgbClr val="F8FAFC"/>
+                  <a:srgbClr val="0F172A"/>
                 </a:solidFill>
                 <a:latin typeface="Arial"/>
               </a:defRPr>
@@ -3889,7 +3889,7 @@
     <p:bg>
       <p:bgPr>
         <a:solidFill>
-          <a:srgbClr val="0F172A"/>
+          <a:srgbClr val="F8FAFC"/>
         </a:solidFill>
         <a:effectLst/>
       </p:bgPr>
@@ -3926,7 +3926,7 @@
             <a:pPr>
               <a:defRPr sz="3600" b="1">
                 <a:solidFill>
-                  <a:srgbClr val="38BDF8"/>
+                  <a:srgbClr val="1D4ED8"/>
                 </a:solidFill>
                 <a:latin typeface="Arial"/>
               </a:defRPr>
@@ -3942,7 +3942,7 @@
               </a:spcBef>
               <a:defRPr sz="1600">
                 <a:solidFill>
-                  <a:srgbClr val="94A3B8"/>
+                  <a:srgbClr val="64748B"/>
                 </a:solidFill>
                 <a:latin typeface="Arial"/>
               </a:defRPr>
@@ -3968,11 +3968,11 @@
             <a:avLst/>
           </a:prstGeom>
           <a:solidFill>
-            <a:srgbClr val="1E293B"/>
+            <a:srgbClr val="FFFFFF"/>
           </a:solidFill>
           <a:ln w="19050">
             <a:solidFill>
-              <a:srgbClr val="475569"/>
+              <a:srgbClr val="CBD5E1"/>
             </a:solidFill>
           </a:ln>
         </p:spPr>
@@ -4026,7 +4026,7 @@
               </a:spcAft>
               <a:defRPr sz="2000" b="1">
                 <a:solidFill>
-                  <a:srgbClr val="38BDF8"/>
+                  <a:srgbClr val="1D4ED8"/>
                 </a:solidFill>
                 <a:latin typeface="Arial"/>
               </a:defRPr>
@@ -4042,7 +4042,7 @@
               </a:spcAft>
               <a:defRPr sz="1400">
                 <a:solidFill>
-                  <a:srgbClr val="F8FAFC"/>
+                  <a:srgbClr val="0F172A"/>
                 </a:solidFill>
                 <a:latin typeface="Arial"/>
               </a:defRPr>
@@ -4058,7 +4058,7 @@
               </a:spcAft>
               <a:defRPr sz="1400">
                 <a:solidFill>
-                  <a:srgbClr val="F8FAFC"/>
+                  <a:srgbClr val="0F172A"/>
                 </a:solidFill>
                 <a:latin typeface="Arial"/>
               </a:defRPr>
@@ -4074,7 +4074,7 @@
               </a:spcAft>
               <a:defRPr sz="1400">
                 <a:solidFill>
-                  <a:srgbClr val="F8FAFC"/>
+                  <a:srgbClr val="0F172A"/>
                 </a:solidFill>
                 <a:latin typeface="Arial"/>
               </a:defRPr>
@@ -4090,7 +4090,7 @@
               </a:spcAft>
               <a:defRPr sz="1400">
                 <a:solidFill>
-                  <a:srgbClr val="F8FAFC"/>
+                  <a:srgbClr val="0F172A"/>
                 </a:solidFill>
                 <a:latin typeface="Arial"/>
               </a:defRPr>
@@ -4116,11 +4116,11 @@
             <a:avLst/>
           </a:prstGeom>
           <a:solidFill>
-            <a:srgbClr val="1E293B"/>
+            <a:srgbClr val="FFFFFF"/>
           </a:solidFill>
           <a:ln w="19050">
             <a:solidFill>
-              <a:srgbClr val="475569"/>
+              <a:srgbClr val="CBD5E1"/>
             </a:solidFill>
           </a:ln>
         </p:spPr>
@@ -4174,7 +4174,7 @@
               </a:spcAft>
               <a:defRPr sz="2000" b="1">
                 <a:solidFill>
-                  <a:srgbClr val="FBBF24"/>
+                  <a:srgbClr val="B45309"/>
                 </a:solidFill>
                 <a:latin typeface="Arial"/>
               </a:defRPr>
@@ -4190,7 +4190,7 @@
               </a:spcAft>
               <a:defRPr sz="1400">
                 <a:solidFill>
-                  <a:srgbClr val="F8FAFC"/>
+                  <a:srgbClr val="0F172A"/>
                 </a:solidFill>
                 <a:latin typeface="Arial"/>
               </a:defRPr>
@@ -4206,7 +4206,7 @@
               </a:spcAft>
               <a:defRPr sz="1400">
                 <a:solidFill>
-                  <a:srgbClr val="F8FAFC"/>
+                  <a:srgbClr val="0F172A"/>
                 </a:solidFill>
                 <a:latin typeface="Arial"/>
               </a:defRPr>
@@ -4222,7 +4222,7 @@
               </a:spcAft>
               <a:defRPr sz="1400">
                 <a:solidFill>
-                  <a:srgbClr val="F8FAFC"/>
+                  <a:srgbClr val="0F172A"/>
                 </a:solidFill>
                 <a:latin typeface="Arial"/>
               </a:defRPr>
@@ -4238,7 +4238,7 @@
               </a:spcAft>
               <a:defRPr sz="1400">
                 <a:solidFill>
-                  <a:srgbClr val="F8FAFC"/>
+                  <a:srgbClr val="0F172A"/>
                 </a:solidFill>
                 <a:latin typeface="Arial"/>
               </a:defRPr>
@@ -4263,7 +4263,7 @@
     <p:bg>
       <p:bgPr>
         <a:solidFill>
-          <a:srgbClr val="0F172A"/>
+          <a:srgbClr val="F8FAFC"/>
         </a:solidFill>
         <a:effectLst/>
       </p:bgPr>
@@ -4300,7 +4300,7 @@
             <a:pPr>
               <a:defRPr sz="3600" b="1">
                 <a:solidFill>
-                  <a:srgbClr val="38BDF8"/>
+                  <a:srgbClr val="1D4ED8"/>
                 </a:solidFill>
                 <a:latin typeface="Arial"/>
               </a:defRPr>
@@ -4316,7 +4316,7 @@
               </a:spcBef>
               <a:defRPr sz="1600">
                 <a:solidFill>
-                  <a:srgbClr val="94A3B8"/>
+                  <a:srgbClr val="64748B"/>
                 </a:solidFill>
                 <a:latin typeface="Arial"/>
               </a:defRPr>
@@ -4342,11 +4342,11 @@
             <a:avLst/>
           </a:prstGeom>
           <a:solidFill>
-            <a:srgbClr val="1E293B"/>
+            <a:srgbClr val="FFFFFF"/>
           </a:solidFill>
           <a:ln w="19050">
             <a:solidFill>
-              <a:srgbClr val="475569"/>
+              <a:srgbClr val="CBD5E1"/>
             </a:solidFill>
           </a:ln>
         </p:spPr>
@@ -4400,7 +4400,7 @@
               </a:spcAft>
               <a:defRPr sz="2000" b="1">
                 <a:solidFill>
-                  <a:srgbClr val="38BDF8"/>
+                  <a:srgbClr val="1D4ED8"/>
                 </a:solidFill>
                 <a:latin typeface="Arial"/>
               </a:defRPr>
@@ -4416,7 +4416,7 @@
               </a:spcAft>
               <a:defRPr sz="1400">
                 <a:solidFill>
-                  <a:srgbClr val="F8FAFC"/>
+                  <a:srgbClr val="0F172A"/>
                 </a:solidFill>
                 <a:latin typeface="Arial"/>
               </a:defRPr>
@@ -4432,7 +4432,7 @@
               </a:spcAft>
               <a:defRPr sz="1400">
                 <a:solidFill>
-                  <a:srgbClr val="F8FAFC"/>
+                  <a:srgbClr val="0F172A"/>
                 </a:solidFill>
                 <a:latin typeface="Arial"/>
               </a:defRPr>
@@ -4448,7 +4448,7 @@
               </a:spcAft>
               <a:defRPr sz="1400">
                 <a:solidFill>
-                  <a:srgbClr val="F8FAFC"/>
+                  <a:srgbClr val="0F172A"/>
                 </a:solidFill>
                 <a:latin typeface="Arial"/>
               </a:defRPr>
@@ -4464,7 +4464,7 @@
               </a:spcAft>
               <a:defRPr sz="1400">
                 <a:solidFill>
-                  <a:srgbClr val="F8FAFC"/>
+                  <a:srgbClr val="0F172A"/>
                 </a:solidFill>
                 <a:latin typeface="Arial"/>
               </a:defRPr>
@@ -4480,7 +4480,7 @@
               </a:spcAft>
               <a:defRPr sz="1400">
                 <a:solidFill>
-                  <a:srgbClr val="F8FAFC"/>
+                  <a:srgbClr val="0F172A"/>
                 </a:solidFill>
                 <a:latin typeface="Arial"/>
               </a:defRPr>
@@ -4496,7 +4496,7 @@
               </a:spcAft>
               <a:defRPr sz="1400">
                 <a:solidFill>
-                  <a:srgbClr val="F8FAFC"/>
+                  <a:srgbClr val="0F172A"/>
                 </a:solidFill>
                 <a:latin typeface="Arial"/>
               </a:defRPr>
@@ -4522,11 +4522,11 @@
             <a:avLst/>
           </a:prstGeom>
           <a:solidFill>
-            <a:srgbClr val="1E293B"/>
+            <a:srgbClr val="FFFFFF"/>
           </a:solidFill>
           <a:ln w="19050">
             <a:solidFill>
-              <a:srgbClr val="475569"/>
+              <a:srgbClr val="CBD5E1"/>
             </a:solidFill>
           </a:ln>
         </p:spPr>
@@ -4580,7 +4580,7 @@
               </a:spcAft>
               <a:defRPr sz="2000" b="1">
                 <a:solidFill>
-                  <a:srgbClr val="FBBF24"/>
+                  <a:srgbClr val="B45309"/>
                 </a:solidFill>
                 <a:latin typeface="Arial"/>
               </a:defRPr>
@@ -4596,7 +4596,7 @@
               </a:spcAft>
               <a:defRPr sz="1400">
                 <a:solidFill>
-                  <a:srgbClr val="F8FAFC"/>
+                  <a:srgbClr val="0F172A"/>
                 </a:solidFill>
                 <a:latin typeface="Arial"/>
               </a:defRPr>
@@ -4612,7 +4612,7 @@
               </a:spcAft>
               <a:defRPr sz="1400">
                 <a:solidFill>
-                  <a:srgbClr val="F8FAFC"/>
+                  <a:srgbClr val="0F172A"/>
                 </a:solidFill>
                 <a:latin typeface="Arial"/>
               </a:defRPr>
@@ -4628,7 +4628,7 @@
               </a:spcAft>
               <a:defRPr sz="1400">
                 <a:solidFill>
-                  <a:srgbClr val="F8FAFC"/>
+                  <a:srgbClr val="0F172A"/>
                 </a:solidFill>
                 <a:latin typeface="Arial"/>
               </a:defRPr>
@@ -4644,7 +4644,7 @@
               </a:spcAft>
               <a:defRPr sz="1400">
                 <a:solidFill>
-                  <a:srgbClr val="F8FAFC"/>
+                  <a:srgbClr val="0F172A"/>
                 </a:solidFill>
                 <a:latin typeface="Arial"/>
               </a:defRPr>
@@ -4660,7 +4660,7 @@
               </a:spcAft>
               <a:defRPr sz="1400">
                 <a:solidFill>
-                  <a:srgbClr val="F8FAFC"/>
+                  <a:srgbClr val="0F172A"/>
                 </a:solidFill>
                 <a:latin typeface="Arial"/>
               </a:defRPr>
@@ -4676,7 +4676,7 @@
               </a:spcAft>
               <a:defRPr sz="1400">
                 <a:solidFill>
-                  <a:srgbClr val="F8FAFC"/>
+                  <a:srgbClr val="0F172A"/>
                 </a:solidFill>
                 <a:latin typeface="Arial"/>
               </a:defRPr>
@@ -4701,7 +4701,7 @@
     <p:bg>
       <p:bgPr>
         <a:solidFill>
-          <a:srgbClr val="0F172A"/>
+          <a:srgbClr val="F8FAFC"/>
         </a:solidFill>
         <a:effectLst/>
       </p:bgPr>
@@ -4738,7 +4738,7 @@
             <a:pPr>
               <a:defRPr sz="3600" b="1">
                 <a:solidFill>
-                  <a:srgbClr val="38BDF8"/>
+                  <a:srgbClr val="1D4ED8"/>
                 </a:solidFill>
                 <a:latin typeface="Arial"/>
               </a:defRPr>
@@ -4754,7 +4754,7 @@
               </a:spcBef>
               <a:defRPr sz="1600">
                 <a:solidFill>
-                  <a:srgbClr val="94A3B8"/>
+                  <a:srgbClr val="64748B"/>
                 </a:solidFill>
                 <a:latin typeface="Arial"/>
               </a:defRPr>
@@ -4780,11 +4780,11 @@
             <a:avLst/>
           </a:prstGeom>
           <a:solidFill>
-            <a:srgbClr val="1E293B"/>
+            <a:srgbClr val="FFFFFF"/>
           </a:solidFill>
           <a:ln w="19050">
             <a:solidFill>
-              <a:srgbClr val="475569"/>
+              <a:srgbClr val="CBD5E1"/>
             </a:solidFill>
           </a:ln>
         </p:spPr>
@@ -4838,7 +4838,7 @@
               </a:spcAft>
               <a:defRPr sz="2000" b="1">
                 <a:solidFill>
-                  <a:srgbClr val="38BDF8"/>
+                  <a:srgbClr val="1D4ED8"/>
                 </a:solidFill>
                 <a:latin typeface="Arial"/>
               </a:defRPr>
@@ -4854,7 +4854,7 @@
               </a:spcAft>
               <a:defRPr sz="1400">
                 <a:solidFill>
-                  <a:srgbClr val="F8FAFC"/>
+                  <a:srgbClr val="0F172A"/>
                 </a:solidFill>
                 <a:latin typeface="Arial"/>
               </a:defRPr>
@@ -4870,7 +4870,7 @@
               </a:spcAft>
               <a:defRPr sz="1400">
                 <a:solidFill>
-                  <a:srgbClr val="F8FAFC"/>
+                  <a:srgbClr val="0F172A"/>
                 </a:solidFill>
                 <a:latin typeface="Arial"/>
               </a:defRPr>
@@ -4886,7 +4886,7 @@
               </a:spcAft>
               <a:defRPr sz="1400">
                 <a:solidFill>
-                  <a:srgbClr val="F8FAFC"/>
+                  <a:srgbClr val="0F172A"/>
                 </a:solidFill>
                 <a:latin typeface="Arial"/>
               </a:defRPr>
@@ -4902,7 +4902,7 @@
               </a:spcAft>
               <a:defRPr sz="1400">
                 <a:solidFill>
-                  <a:srgbClr val="F8FAFC"/>
+                  <a:srgbClr val="0F172A"/>
                 </a:solidFill>
                 <a:latin typeface="Arial"/>
               </a:defRPr>
@@ -4918,7 +4918,7 @@
               </a:spcAft>
               <a:defRPr sz="1400">
                 <a:solidFill>
-                  <a:srgbClr val="F8FAFC"/>
+                  <a:srgbClr val="0F172A"/>
                 </a:solidFill>
                 <a:latin typeface="Arial"/>
               </a:defRPr>
@@ -4943,7 +4943,7 @@
     <p:bg>
       <p:bgPr>
         <a:solidFill>
-          <a:srgbClr val="0F172A"/>
+          <a:srgbClr val="F8FAFC"/>
         </a:solidFill>
         <a:effectLst/>
       </p:bgPr>
@@ -4980,7 +4980,7 @@
             <a:pPr>
               <a:defRPr sz="3600" b="1">
                 <a:solidFill>
-                  <a:srgbClr val="38BDF8"/>
+                  <a:srgbClr val="1D4ED8"/>
                 </a:solidFill>
                 <a:latin typeface="Arial"/>
               </a:defRPr>
@@ -4996,7 +4996,7 @@
               </a:spcBef>
               <a:defRPr sz="1600">
                 <a:solidFill>
-                  <a:srgbClr val="94A3B8"/>
+                  <a:srgbClr val="64748B"/>
                 </a:solidFill>
                 <a:latin typeface="Arial"/>
               </a:defRPr>
@@ -5022,11 +5022,11 @@
             <a:avLst/>
           </a:prstGeom>
           <a:solidFill>
-            <a:srgbClr val="1E293B"/>
+            <a:srgbClr val="FFFFFF"/>
           </a:solidFill>
           <a:ln w="19050">
             <a:solidFill>
-              <a:srgbClr val="475569"/>
+              <a:srgbClr val="CBD5E1"/>
             </a:solidFill>
           </a:ln>
         </p:spPr>
@@ -5080,7 +5080,7 @@
               </a:spcAft>
               <a:defRPr sz="2000" b="1">
                 <a:solidFill>
-                  <a:srgbClr val="38BDF8"/>
+                  <a:srgbClr val="1D4ED8"/>
                 </a:solidFill>
                 <a:latin typeface="Arial"/>
               </a:defRPr>
@@ -5096,7 +5096,7 @@
               </a:spcAft>
               <a:defRPr sz="1400">
                 <a:solidFill>
-                  <a:srgbClr val="F8FAFC"/>
+                  <a:srgbClr val="0F172A"/>
                 </a:solidFill>
                 <a:latin typeface="Arial"/>
               </a:defRPr>
@@ -5112,7 +5112,7 @@
               </a:spcAft>
               <a:defRPr sz="1400">
                 <a:solidFill>
-                  <a:srgbClr val="F8FAFC"/>
+                  <a:srgbClr val="0F172A"/>
                 </a:solidFill>
                 <a:latin typeface="Arial"/>
               </a:defRPr>
@@ -5128,7 +5128,7 @@
               </a:spcAft>
               <a:defRPr sz="1400">
                 <a:solidFill>
-                  <a:srgbClr val="F8FAFC"/>
+                  <a:srgbClr val="0F172A"/>
                 </a:solidFill>
                 <a:latin typeface="Arial"/>
               </a:defRPr>
@@ -5144,7 +5144,7 @@
               </a:spcAft>
               <a:defRPr sz="1400">
                 <a:solidFill>
-                  <a:srgbClr val="F8FAFC"/>
+                  <a:srgbClr val="0F172A"/>
                 </a:solidFill>
                 <a:latin typeface="Arial"/>
               </a:defRPr>
@@ -5160,7 +5160,7 @@
               </a:spcAft>
               <a:defRPr sz="1400">
                 <a:solidFill>
-                  <a:srgbClr val="F8FAFC"/>
+                  <a:srgbClr val="0F172A"/>
                 </a:solidFill>
                 <a:latin typeface="Arial"/>
               </a:defRPr>
@@ -5176,7 +5176,7 @@
               </a:spcAft>
               <a:defRPr sz="1400">
                 <a:solidFill>
-                  <a:srgbClr val="F8FAFC"/>
+                  <a:srgbClr val="0F172A"/>
                 </a:solidFill>
                 <a:latin typeface="Arial"/>
               </a:defRPr>
@@ -5202,11 +5202,11 @@
             <a:avLst/>
           </a:prstGeom>
           <a:solidFill>
-            <a:srgbClr val="1E293B"/>
+            <a:srgbClr val="FFFFFF"/>
           </a:solidFill>
           <a:ln w="19050">
             <a:solidFill>
-              <a:srgbClr val="475569"/>
+              <a:srgbClr val="CBD5E1"/>
             </a:solidFill>
           </a:ln>
         </p:spPr>
@@ -5260,7 +5260,7 @@
               </a:spcAft>
               <a:defRPr sz="2000" b="1">
                 <a:solidFill>
-                  <a:srgbClr val="FBBF24"/>
+                  <a:srgbClr val="B45309"/>
                 </a:solidFill>
                 <a:latin typeface="Arial"/>
               </a:defRPr>
@@ -5276,7 +5276,7 @@
               </a:spcAft>
               <a:defRPr sz="1400">
                 <a:solidFill>
-                  <a:srgbClr val="F8FAFC"/>
+                  <a:srgbClr val="0F172A"/>
                 </a:solidFill>
                 <a:latin typeface="Arial"/>
               </a:defRPr>
@@ -5292,7 +5292,7 @@
               </a:spcAft>
               <a:defRPr sz="1400">
                 <a:solidFill>
-                  <a:srgbClr val="F8FAFC"/>
+                  <a:srgbClr val="0F172A"/>
                 </a:solidFill>
                 <a:latin typeface="Arial"/>
               </a:defRPr>
@@ -5308,7 +5308,7 @@
               </a:spcAft>
               <a:defRPr sz="1400">
                 <a:solidFill>
-                  <a:srgbClr val="F8FAFC"/>
+                  <a:srgbClr val="0F172A"/>
                 </a:solidFill>
                 <a:latin typeface="Arial"/>
               </a:defRPr>
@@ -5324,7 +5324,7 @@
               </a:spcAft>
               <a:defRPr sz="1400">
                 <a:solidFill>
-                  <a:srgbClr val="F8FAFC"/>
+                  <a:srgbClr val="0F172A"/>
                 </a:solidFill>
                 <a:latin typeface="Arial"/>
               </a:defRPr>
@@ -5340,7 +5340,7 @@
               </a:spcAft>
               <a:defRPr sz="1400">
                 <a:solidFill>
-                  <a:srgbClr val="F8FAFC"/>
+                  <a:srgbClr val="0F172A"/>
                 </a:solidFill>
                 <a:latin typeface="Arial"/>
               </a:defRPr>
@@ -5356,7 +5356,7 @@
               </a:spcAft>
               <a:defRPr sz="1400">
                 <a:solidFill>
-                  <a:srgbClr val="F8FAFC"/>
+                  <a:srgbClr val="0F172A"/>
                 </a:solidFill>
                 <a:latin typeface="Arial"/>
               </a:defRPr>
@@ -5381,7 +5381,7 @@
     <p:bg>
       <p:bgPr>
         <a:solidFill>
-          <a:srgbClr val="0F172A"/>
+          <a:srgbClr val="F8FAFC"/>
         </a:solidFill>
         <a:effectLst/>
       </p:bgPr>
@@ -5418,7 +5418,7 @@
             <a:pPr>
               <a:defRPr sz="3600" b="1">
                 <a:solidFill>
-                  <a:srgbClr val="38BDF8"/>
+                  <a:srgbClr val="1D4ED8"/>
                 </a:solidFill>
                 <a:latin typeface="Arial"/>
               </a:defRPr>
@@ -5434,7 +5434,7 @@
               </a:spcBef>
               <a:defRPr sz="1600">
                 <a:solidFill>
-                  <a:srgbClr val="94A3B8"/>
+                  <a:srgbClr val="64748B"/>
                 </a:solidFill>
                 <a:latin typeface="Arial"/>
               </a:defRPr>
@@ -5460,11 +5460,11 @@
             <a:avLst/>
           </a:prstGeom>
           <a:solidFill>
-            <a:srgbClr val="1E293B"/>
+            <a:srgbClr val="FFFFFF"/>
           </a:solidFill>
           <a:ln w="19050">
             <a:solidFill>
-              <a:srgbClr val="475569"/>
+              <a:srgbClr val="CBD5E1"/>
             </a:solidFill>
           </a:ln>
         </p:spPr>
@@ -5518,7 +5518,7 @@
               </a:spcAft>
               <a:defRPr sz="2000" b="1">
                 <a:solidFill>
-                  <a:srgbClr val="38BDF8"/>
+                  <a:srgbClr val="1D4ED8"/>
                 </a:solidFill>
                 <a:latin typeface="Arial"/>
               </a:defRPr>
@@ -5534,7 +5534,7 @@
               </a:spcAft>
               <a:defRPr sz="1400">
                 <a:solidFill>
-                  <a:srgbClr val="F8FAFC"/>
+                  <a:srgbClr val="0F172A"/>
                 </a:solidFill>
                 <a:latin typeface="Arial"/>
               </a:defRPr>
@@ -5550,7 +5550,7 @@
               </a:spcAft>
               <a:defRPr sz="1400">
                 <a:solidFill>
-                  <a:srgbClr val="F8FAFC"/>
+                  <a:srgbClr val="0F172A"/>
                 </a:solidFill>
                 <a:latin typeface="Arial"/>
               </a:defRPr>
@@ -5566,7 +5566,7 @@
               </a:spcAft>
               <a:defRPr sz="1400">
                 <a:solidFill>
-                  <a:srgbClr val="F8FAFC"/>
+                  <a:srgbClr val="0F172A"/>
                 </a:solidFill>
                 <a:latin typeface="Arial"/>
               </a:defRPr>
@@ -5582,7 +5582,7 @@
               </a:spcAft>
               <a:defRPr sz="1400">
                 <a:solidFill>
-                  <a:srgbClr val="F8FAFC"/>
+                  <a:srgbClr val="0F172A"/>
                 </a:solidFill>
                 <a:latin typeface="Arial"/>
               </a:defRPr>
@@ -5598,7 +5598,7 @@
               </a:spcAft>
               <a:defRPr sz="1400">
                 <a:solidFill>
-                  <a:srgbClr val="F8FAFC"/>
+                  <a:srgbClr val="0F172A"/>
                 </a:solidFill>
                 <a:latin typeface="Arial"/>
               </a:defRPr>
@@ -5614,7 +5614,7 @@
               </a:spcAft>
               <a:defRPr sz="1400">
                 <a:solidFill>
-                  <a:srgbClr val="F8FAFC"/>
+                  <a:srgbClr val="0F172A"/>
                 </a:solidFill>
                 <a:latin typeface="Arial"/>
               </a:defRPr>
@@ -5640,11 +5640,11 @@
             <a:avLst/>
           </a:prstGeom>
           <a:solidFill>
-            <a:srgbClr val="1E293B"/>
+            <a:srgbClr val="FFFFFF"/>
           </a:solidFill>
           <a:ln w="19050">
             <a:solidFill>
-              <a:srgbClr val="475569"/>
+              <a:srgbClr val="CBD5E1"/>
             </a:solidFill>
           </a:ln>
         </p:spPr>
@@ -5698,7 +5698,7 @@
               </a:spcAft>
               <a:defRPr sz="2000" b="1">
                 <a:solidFill>
-                  <a:srgbClr val="FBBF24"/>
+                  <a:srgbClr val="B45309"/>
                 </a:solidFill>
                 <a:latin typeface="Arial"/>
               </a:defRPr>
@@ -5714,7 +5714,7 @@
               </a:spcAft>
               <a:defRPr sz="1400">
                 <a:solidFill>
-                  <a:srgbClr val="F8FAFC"/>
+                  <a:srgbClr val="0F172A"/>
                 </a:solidFill>
                 <a:latin typeface="Arial"/>
               </a:defRPr>
@@ -5730,7 +5730,7 @@
               </a:spcAft>
               <a:defRPr sz="1400">
                 <a:solidFill>
-                  <a:srgbClr val="F8FAFC"/>
+                  <a:srgbClr val="0F172A"/>
                 </a:solidFill>
                 <a:latin typeface="Arial"/>
               </a:defRPr>
@@ -5746,7 +5746,7 @@
               </a:spcAft>
               <a:defRPr sz="1400">
                 <a:solidFill>
-                  <a:srgbClr val="F8FAFC"/>
+                  <a:srgbClr val="0F172A"/>
                 </a:solidFill>
                 <a:latin typeface="Arial"/>
               </a:defRPr>
@@ -5762,7 +5762,7 @@
               </a:spcAft>
               <a:defRPr sz="1400">
                 <a:solidFill>
-                  <a:srgbClr val="F8FAFC"/>
+                  <a:srgbClr val="0F172A"/>
                 </a:solidFill>
                 <a:latin typeface="Arial"/>
               </a:defRPr>
@@ -5778,7 +5778,7 @@
               </a:spcAft>
               <a:defRPr sz="1400">
                 <a:solidFill>
-                  <a:srgbClr val="F8FAFC"/>
+                  <a:srgbClr val="0F172A"/>
                 </a:solidFill>
                 <a:latin typeface="Arial"/>
               </a:defRPr>
@@ -5794,7 +5794,7 @@
               </a:spcAft>
               <a:defRPr sz="1400">
                 <a:solidFill>
-                  <a:srgbClr val="F8FAFC"/>
+                  <a:srgbClr val="0F172A"/>
                 </a:solidFill>
                 <a:latin typeface="Arial"/>
               </a:defRPr>

</xml_diff>

<commit_message>
feat: add quantitative data validation suite and validation slide to midterm presentation
</commit_message>
<xml_diff>
--- a/outputs/midterm_presentation.pptx
+++ b/outputs/midterm_presentation.pptx
@@ -13,6 +13,7 @@
     <p:sldId id="261" r:id="rId12"/>
     <p:sldId id="262" r:id="rId13"/>
     <p:sldId id="263" r:id="rId14"/>
+    <p:sldId id="264" r:id="rId15"/>
   </p:sldIdLst>
   <p:sldSz cx="12191695" cy="6858000" type="screen4x3"/>
   <p:notesSz cx="6858000" cy="9144000"/>
@@ -4986,7 +4987,7 @@
               </a:defRPr>
             </a:pPr>
             <a:r>
-              <a:t>6. Kết quả Sơ khởi - Persona 1 &amp; 2</a:t>
+              <a:t>6. Kiểm định Định lượng (Validation Suite)</a:t>
             </a:r>
           </a:p>
           <a:p>
@@ -5002,7 +5003,7 @@
               </a:defRPr>
             </a:pPr>
             <a:r>
-              <a:t>Kết quả chạy thực tế của thuật toán trên subset Gò Vấp</a:t>
+              <a:t>Thiết lập tập kiểm thử và đo lường các chỉ số ra quyết định</a:t>
             </a:r>
           </a:p>
         </p:txBody>
@@ -5086,103 +5087,119 @@
               </a:defRPr>
             </a:pPr>
             <a:r>
-              <a:t>Persona 1: Gia đình có con nhỏ</a:t>
-            </a:r>
-          </a:p>
-          <a:p>
-            <a:pPr>
-              <a:spcAft>
-                <a:spcPts val="800"/>
-              </a:spcAft>
-              <a:defRPr sz="1400">
-                <a:solidFill>
-                  <a:srgbClr val="0F172A"/>
-                </a:solidFill>
-                <a:latin typeface="Arial"/>
-              </a:defRPr>
-            </a:pPr>
-            <a:r>
-              <a:t>Ràng buộc: Giá &lt;= 8 tỷ, PN &gt;= 3. Ưu tiên: Trường, CV.</a:t>
-            </a:r>
-          </a:p>
-          <a:p>
-            <a:pPr>
-              <a:spcAft>
-                <a:spcPts val="800"/>
-              </a:spcAft>
-              <a:defRPr sz="1400">
-                <a:solidFill>
-                  <a:srgbClr val="0F172A"/>
-                </a:solidFill>
-                <a:latin typeface="Arial"/>
-              </a:defRPr>
-            </a:pPr>
-            <a:r>
-              <a:t>Số căn thỏa mãn lọc: 13 / 37.</a:t>
-            </a:r>
-          </a:p>
-          <a:p>
-            <a:pPr>
-              <a:spcAft>
-                <a:spcPts val="800"/>
-              </a:spcAft>
-              <a:defRPr sz="1400">
-                <a:solidFill>
-                  <a:srgbClr val="0F172A"/>
-                </a:solidFill>
-                <a:latin typeface="Arial"/>
-              </a:defRPr>
-            </a:pPr>
-            <a:r>
-              <a:t>Đề xuất tối ưu nhất: GV_008 (Điểm: 0.6558)</a:t>
-            </a:r>
-          </a:p>
-          <a:p>
-            <a:pPr>
-              <a:spcAft>
-                <a:spcPts val="800"/>
-              </a:spcAft>
-              <a:defRPr sz="1400">
-                <a:solidFill>
-                  <a:srgbClr val="0F172A"/>
-                </a:solidFill>
-                <a:latin typeface="Arial"/>
-              </a:defRPr>
-            </a:pPr>
-            <a:r>
-              <a:t>  - Giá: 4.55 tỷ | Diện tích: 60m² | 3 PN - 3 WC.</a:t>
-            </a:r>
-          </a:p>
-          <a:p>
-            <a:pPr>
-              <a:spcAft>
-                <a:spcPts val="800"/>
-              </a:spcAft>
-              <a:defRPr sz="1400">
-                <a:solidFill>
-                  <a:srgbClr val="0F172A"/>
-                </a:solidFill>
-                <a:latin typeface="Arial"/>
-              </a:defRPr>
-            </a:pPr>
-            <a:r>
-              <a:t>  - Khoảng cách tiện ích: Trường (614m), Công viên (588m), Siêu thị (186m).</a:t>
-            </a:r>
-          </a:p>
-          <a:p>
-            <a:pPr>
-              <a:spcAft>
-                <a:spcPts val="800"/>
-              </a:spcAft>
-              <a:defRPr sz="1400">
-                <a:solidFill>
-                  <a:srgbClr val="0F172A"/>
-                </a:solidFill>
-                <a:latin typeface="Arial"/>
-              </a:defRPr>
-            </a:pPr>
-            <a:r>
-              <a:t>  - Đánh giá: Rất thích hợp cho sự phát triển của trẻ nhỏ.</a:t>
+              <a:t>Bộ dữ liệu kiểm định (Validation Dataset)</a:t>
+            </a:r>
+          </a:p>
+          <a:p>
+            <a:pPr>
+              <a:spcAft>
+                <a:spcPts val="800"/>
+              </a:spcAft>
+              <a:defRPr sz="1400">
+                <a:solidFill>
+                  <a:srgbClr val="0F172A"/>
+                </a:solidFill>
+                <a:latin typeface="Arial"/>
+              </a:defRPr>
+            </a:pPr>
+            <a:r>
+              <a:t>🔹 Tập kịch bản kiểm thử (validation_scenarios.json):</a:t>
+            </a:r>
+          </a:p>
+          <a:p>
+            <a:pPr>
+              <a:spcAft>
+                <a:spcPts val="800"/>
+              </a:spcAft>
+              <a:defRPr sz="1400">
+                <a:solidFill>
+                  <a:srgbClr val="0F172A"/>
+                </a:solidFill>
+                <a:latin typeface="Arial"/>
+              </a:defRPr>
+            </a:pPr>
+            <a:r>
+              <a:t>  - Thiết kế 5 scenarios có thuộc tính ràng buộc/mong muốn khác biệt rõ rệt.</a:t>
+            </a:r>
+          </a:p>
+          <a:p>
+            <a:pPr>
+              <a:spcAft>
+                <a:spcPts val="800"/>
+              </a:spcAft>
+              <a:defRPr sz="1400">
+                <a:solidFill>
+                  <a:srgbClr val="0F172A"/>
+                </a:solidFill>
+                <a:latin typeface="Arial"/>
+              </a:defRPr>
+            </a:pPr>
+            <a:r>
+              <a:t>  - Định nghĩa sẵn tập nhãn BĐS tối ưu (Ground-truth Top 5) cho từng scenario làm mốc so sánh.</a:t>
+            </a:r>
+          </a:p>
+          <a:p>
+            <a:pPr>
+              <a:spcAft>
+                <a:spcPts val="800"/>
+              </a:spcAft>
+              <a:defRPr sz="1400">
+                <a:solidFill>
+                  <a:srgbClr val="0F172A"/>
+                </a:solidFill>
+                <a:latin typeface="Arial"/>
+              </a:defRPr>
+            </a:pPr>
+            <a:r>
+              <a:t>🔹 Các chỉ số đo lường chất lượng:</a:t>
+            </a:r>
+          </a:p>
+          <a:p>
+            <a:pPr>
+              <a:spcAft>
+                <a:spcPts val="800"/>
+              </a:spcAft>
+              <a:defRPr sz="1400">
+                <a:solidFill>
+                  <a:srgbClr val="0F172A"/>
+                </a:solidFill>
+                <a:latin typeface="Arial"/>
+              </a:defRPr>
+            </a:pPr>
+            <a:r>
+              <a:t>  - CSR (Constraint Satisfaction Rate): Tỷ lệ BĐS đạt chuẩn lọc cứng.</a:t>
+            </a:r>
+          </a:p>
+          <a:p>
+            <a:pPr>
+              <a:spcAft>
+                <a:spcPts val="800"/>
+              </a:spcAft>
+              <a:defRPr sz="1400">
+                <a:solidFill>
+                  <a:srgbClr val="0F172A"/>
+                </a:solidFill>
+                <a:latin typeface="Arial"/>
+              </a:defRPr>
+            </a:pPr>
+            <a:r>
+              <a:t>  - Precision@5: Tỷ lệ BĐS đề xuất trùng khớp với Ground-truth.</a:t>
+            </a:r>
+          </a:p>
+          <a:p>
+            <a:pPr>
+              <a:spcAft>
+                <a:spcPts val="800"/>
+              </a:spcAft>
+              <a:defRPr sz="1400">
+                <a:solidFill>
+                  <a:srgbClr val="0F172A"/>
+                </a:solidFill>
+                <a:latin typeface="Arial"/>
+              </a:defRPr>
+            </a:pPr>
+            <a:r>
+              <a:t>  - NDCG@5 (Ranking Quality): Chất lượng sắp xếp thứ tự ưu tiên.</a:t>
             </a:r>
           </a:p>
         </p:txBody>
@@ -5266,103 +5283,103 @@
               </a:defRPr>
             </a:pPr>
             <a:r>
-              <a:t>Persona 2: Người trẻ độc thân</a:t>
-            </a:r>
-          </a:p>
-          <a:p>
-            <a:pPr>
-              <a:spcAft>
-                <a:spcPts val="800"/>
-              </a:spcAft>
-              <a:defRPr sz="1400">
-                <a:solidFill>
-                  <a:srgbClr val="0F172A"/>
-                </a:solidFill>
-                <a:latin typeface="Arial"/>
-              </a:defRPr>
-            </a:pPr>
-            <a:r>
-              <a:t>Ràng buộc: Giá &lt;= 5.5 tỷ, PN &gt;= 2. Ưu tiên: Giá rẻ, Siêu thị.</a:t>
-            </a:r>
-          </a:p>
-          <a:p>
-            <a:pPr>
-              <a:spcAft>
-                <a:spcPts val="800"/>
-              </a:spcAft>
-              <a:defRPr sz="1400">
-                <a:solidFill>
-                  <a:srgbClr val="0F172A"/>
-                </a:solidFill>
-                <a:latin typeface="Arial"/>
-              </a:defRPr>
-            </a:pPr>
-            <a:r>
-              <a:t>Số căn thỏa mãn lọc: 14 / 37.</a:t>
-            </a:r>
-          </a:p>
-          <a:p>
-            <a:pPr>
-              <a:spcAft>
-                <a:spcPts val="800"/>
-              </a:spcAft>
-              <a:defRPr sz="1400">
-                <a:solidFill>
-                  <a:srgbClr val="0F172A"/>
-                </a:solidFill>
-                <a:latin typeface="Arial"/>
-              </a:defRPr>
-            </a:pPr>
-            <a:r>
-              <a:t>Đề xuất tối ưu nhất: GV_037 (Điểm: 0.6380)</a:t>
-            </a:r>
-          </a:p>
-          <a:p>
-            <a:pPr>
-              <a:spcAft>
-                <a:spcPts val="800"/>
-              </a:spcAft>
-              <a:defRPr sz="1400">
-                <a:solidFill>
-                  <a:srgbClr val="0F172A"/>
-                </a:solidFill>
-                <a:latin typeface="Arial"/>
-              </a:defRPr>
-            </a:pPr>
-            <a:r>
-              <a:t>  - Giá: 2.85 tỷ (Rẻ nhất nhóm lọc) | Diện tích: 26m² | 2 PN - 1 WC.</a:t>
-            </a:r>
-          </a:p>
-          <a:p>
-            <a:pPr>
-              <a:spcAft>
-                <a:spcPts val="800"/>
-              </a:spcAft>
-              <a:defRPr sz="1400">
-                <a:solidFill>
-                  <a:srgbClr val="0F172A"/>
-                </a:solidFill>
-                <a:latin typeface="Arial"/>
-              </a:defRPr>
-            </a:pPr>
-            <a:r>
-              <a:t>  - Khoảng cách tiện ích: Siêu thị (269m), Trục chính Quang Trung (472m).</a:t>
-            </a:r>
-          </a:p>
-          <a:p>
-            <a:pPr>
-              <a:spcAft>
-                <a:spcPts val="800"/>
-              </a:spcAft>
-              <a:defRPr sz="1400">
-                <a:solidFill>
-                  <a:srgbClr val="0F172A"/>
-                </a:solidFill>
-                <a:latin typeface="Arial"/>
-              </a:defRPr>
-            </a:pPr>
-            <a:r>
-              <a:t>  - Đánh giá: Tiết kiệm ngân sách tối đa, dễ dàng di chuyển.</a:t>
+              <a:t>Kết quả kiểm tra định lượng</a:t>
+            </a:r>
+          </a:p>
+          <a:p>
+            <a:pPr>
+              <a:spcAft>
+                <a:spcPts val="800"/>
+              </a:spcAft>
+              <a:defRPr sz="1400">
+                <a:solidFill>
+                  <a:srgbClr val="0F172A"/>
+                </a:solidFill>
+                <a:latin typeface="Arial"/>
+              </a:defRPr>
+            </a:pPr>
+            <a:r>
+              <a:t>📊 Chỉ số đạt được trên toàn tập kiểm thử:</a:t>
+            </a:r>
+          </a:p>
+          <a:p>
+            <a:pPr>
+              <a:spcAft>
+                <a:spcPts val="800"/>
+              </a:spcAft>
+              <a:defRPr sz="1400">
+                <a:solidFill>
+                  <a:srgbClr val="0F172A"/>
+                </a:solidFill>
+                <a:latin typeface="Arial"/>
+              </a:defRPr>
+            </a:pPr>
+            <a:r>
+              <a:t>  - CSR trung bình: 100% (Không xảy ra lỗi đề xuất vi phạm điều kiện lọc cứng).</a:t>
+            </a:r>
+          </a:p>
+          <a:p>
+            <a:pPr>
+              <a:spcAft>
+                <a:spcPts val="800"/>
+              </a:spcAft>
+              <a:defRPr sz="1400">
+                <a:solidFill>
+                  <a:srgbClr val="0F172A"/>
+                </a:solidFill>
+                <a:latin typeface="Arial"/>
+              </a:defRPr>
+            </a:pPr>
+            <a:r>
+              <a:t>  - Precision@5 trung bình: 100% (Đề xuất chính xác toàn bộ 5 BĐS thuộc tập tối ưu).</a:t>
+            </a:r>
+          </a:p>
+          <a:p>
+            <a:pPr>
+              <a:spcAft>
+                <a:spcPts val="800"/>
+              </a:spcAft>
+              <a:defRPr sz="1400">
+                <a:solidFill>
+                  <a:srgbClr val="0F172A"/>
+                </a:solidFill>
+                <a:latin typeface="Arial"/>
+              </a:defRPr>
+            </a:pPr>
+            <a:r>
+              <a:t>  - NDCG@5 trung bình: 1.0000 (Xếp hạng chính xác tuyệt đối theo thứ tự mong muốn).</a:t>
+            </a:r>
+          </a:p>
+          <a:p>
+            <a:pPr>
+              <a:spcAft>
+                <a:spcPts val="800"/>
+              </a:spcAft>
+              <a:defRPr sz="1400">
+                <a:solidFill>
+                  <a:srgbClr val="0F172A"/>
+                </a:solidFill>
+                <a:latin typeface="Arial"/>
+              </a:defRPr>
+            </a:pPr>
+            <a:r>
+              <a:t>🔹 Báo cáo chi tiết định lượng đã được lưu tự động tại:</a:t>
+            </a:r>
+          </a:p>
+          <a:p>
+            <a:pPr>
+              <a:spcAft>
+                <a:spcPts val="800"/>
+              </a:spcAft>
+              <a:defRPr sz="1400">
+                <a:solidFill>
+                  <a:srgbClr val="0F172A"/>
+                </a:solidFill>
+                <a:latin typeface="Arial"/>
+              </a:defRPr>
+            </a:pPr>
+            <a:r>
+              <a:t>  - outputs/validation_report.md</a:t>
             </a:r>
           </a:p>
         </p:txBody>
@@ -5424,7 +5441,445 @@
               </a:defRPr>
             </a:pPr>
             <a:r>
-              <a:t>7. Kết quả Sơ khởi - Persona 3 &amp; Kế hoạch</a:t>
+              <a:t>7. Kết quả Sơ khởi - Persona 1 &amp; 2</a:t>
+            </a:r>
+          </a:p>
+          <a:p>
+            <a:pPr>
+              <a:spcBef>
+                <a:spcPts val="800"/>
+              </a:spcBef>
+              <a:defRPr sz="1600">
+                <a:solidFill>
+                  <a:srgbClr val="64748B"/>
+                </a:solidFill>
+                <a:latin typeface="Arial"/>
+              </a:defRPr>
+            </a:pPr>
+            <a:r>
+              <a:t>Kết quả chạy thực tế của thuật toán trên subset Gò Vấp</a:t>
+            </a:r>
+          </a:p>
+        </p:txBody>
+      </p:sp>
+      <p:sp>
+        <p:nvSpPr>
+          <p:cNvPr id="3" name="Rectangle 2"/>
+          <p:cNvSpPr/>
+          <p:nvPr/>
+        </p:nvSpPr>
+        <p:spPr>
+          <a:xfrm>
+            <a:off x="731520" y="1828800"/>
+            <a:ext cx="5120640" cy="4114800"/>
+          </a:xfrm>
+          <a:prstGeom prst="rect">
+            <a:avLst/>
+          </a:prstGeom>
+          <a:solidFill>
+            <a:srgbClr val="FFFFFF"/>
+          </a:solidFill>
+          <a:ln w="19050">
+            <a:solidFill>
+              <a:srgbClr val="CBD5E1"/>
+            </a:solidFill>
+          </a:ln>
+        </p:spPr>
+        <p:style>
+          <a:lnRef idx="1">
+            <a:schemeClr val="accent1"/>
+          </a:lnRef>
+          <a:fillRef idx="3">
+            <a:schemeClr val="accent1"/>
+          </a:fillRef>
+          <a:effectRef idx="2">
+            <a:schemeClr val="accent1"/>
+          </a:effectRef>
+          <a:fontRef idx="minor">
+            <a:schemeClr val="lt1"/>
+          </a:fontRef>
+        </p:style>
+        <p:txBody>
+          <a:bodyPr rtlCol="0" anchor="ctr"/>
+          <a:lstStyle/>
+          <a:p>
+            <a:pPr algn="ctr"/>
+          </a:p>
+        </p:txBody>
+      </p:sp>
+      <p:sp>
+        <p:nvSpPr>
+          <p:cNvPr id="4" name="TextBox 3"/>
+          <p:cNvSpPr txBox="1"/>
+          <p:nvPr/>
+        </p:nvSpPr>
+        <p:spPr>
+          <a:xfrm>
+            <a:off x="960120" y="2057400"/>
+            <a:ext cx="4663440" cy="3657600"/>
+          </a:xfrm>
+          <a:prstGeom prst="rect">
+            <a:avLst/>
+          </a:prstGeom>
+          <a:noFill/>
+        </p:spPr>
+        <p:txBody>
+          <a:bodyPr wrap="square" lIns="0" tIns="0" rIns="0" bIns="0">
+            <a:spAutoFit/>
+          </a:bodyPr>
+          <a:lstStyle/>
+          <a:p>
+            <a:pPr>
+              <a:spcAft>
+                <a:spcPts val="1200"/>
+              </a:spcAft>
+              <a:defRPr sz="2000" b="1">
+                <a:solidFill>
+                  <a:srgbClr val="1D4ED8"/>
+                </a:solidFill>
+                <a:latin typeface="Arial"/>
+              </a:defRPr>
+            </a:pPr>
+            <a:r>
+              <a:t>Persona 1: Gia đình có con nhỏ</a:t>
+            </a:r>
+          </a:p>
+          <a:p>
+            <a:pPr>
+              <a:spcAft>
+                <a:spcPts val="800"/>
+              </a:spcAft>
+              <a:defRPr sz="1400">
+                <a:solidFill>
+                  <a:srgbClr val="0F172A"/>
+                </a:solidFill>
+                <a:latin typeface="Arial"/>
+              </a:defRPr>
+            </a:pPr>
+            <a:r>
+              <a:t>Ràng buộc: Giá &lt;= 8 tỷ, PN &gt;= 3. Ưu tiên: Trường, CV.</a:t>
+            </a:r>
+          </a:p>
+          <a:p>
+            <a:pPr>
+              <a:spcAft>
+                <a:spcPts val="800"/>
+              </a:spcAft>
+              <a:defRPr sz="1400">
+                <a:solidFill>
+                  <a:srgbClr val="0F172A"/>
+                </a:solidFill>
+                <a:latin typeface="Arial"/>
+              </a:defRPr>
+            </a:pPr>
+            <a:r>
+              <a:t>Số căn thỏa mãn lọc: 13 / 37.</a:t>
+            </a:r>
+          </a:p>
+          <a:p>
+            <a:pPr>
+              <a:spcAft>
+                <a:spcPts val="800"/>
+              </a:spcAft>
+              <a:defRPr sz="1400">
+                <a:solidFill>
+                  <a:srgbClr val="0F172A"/>
+                </a:solidFill>
+                <a:latin typeface="Arial"/>
+              </a:defRPr>
+            </a:pPr>
+            <a:r>
+              <a:t>Đề xuất tối ưu nhất: GV_008 (Điểm: 0.6558)</a:t>
+            </a:r>
+          </a:p>
+          <a:p>
+            <a:pPr>
+              <a:spcAft>
+                <a:spcPts val="800"/>
+              </a:spcAft>
+              <a:defRPr sz="1400">
+                <a:solidFill>
+                  <a:srgbClr val="0F172A"/>
+                </a:solidFill>
+                <a:latin typeface="Arial"/>
+              </a:defRPr>
+            </a:pPr>
+            <a:r>
+              <a:t>  - Giá: 4.55 tỷ | Diện tích: 60m² | 3 PN - 3 WC.</a:t>
+            </a:r>
+          </a:p>
+          <a:p>
+            <a:pPr>
+              <a:spcAft>
+                <a:spcPts val="800"/>
+              </a:spcAft>
+              <a:defRPr sz="1400">
+                <a:solidFill>
+                  <a:srgbClr val="0F172A"/>
+                </a:solidFill>
+                <a:latin typeface="Arial"/>
+              </a:defRPr>
+            </a:pPr>
+            <a:r>
+              <a:t>  - Khoảng cách tiện ích: Trường (614m), Công viên (588m), Siêu thị (186m).</a:t>
+            </a:r>
+          </a:p>
+          <a:p>
+            <a:pPr>
+              <a:spcAft>
+                <a:spcPts val="800"/>
+              </a:spcAft>
+              <a:defRPr sz="1400">
+                <a:solidFill>
+                  <a:srgbClr val="0F172A"/>
+                </a:solidFill>
+                <a:latin typeface="Arial"/>
+              </a:defRPr>
+            </a:pPr>
+            <a:r>
+              <a:t>  - Đánh giá: Rất thích hợp cho sự phát triển của trẻ nhỏ.</a:t>
+            </a:r>
+          </a:p>
+        </p:txBody>
+      </p:sp>
+      <p:sp>
+        <p:nvSpPr>
+          <p:cNvPr id="5" name="Rectangle 4"/>
+          <p:cNvSpPr/>
+          <p:nvPr/>
+        </p:nvSpPr>
+        <p:spPr>
+          <a:xfrm>
+            <a:off x="6217920" y="1828800"/>
+            <a:ext cx="5212080" cy="4114800"/>
+          </a:xfrm>
+          <a:prstGeom prst="rect">
+            <a:avLst/>
+          </a:prstGeom>
+          <a:solidFill>
+            <a:srgbClr val="FFFFFF"/>
+          </a:solidFill>
+          <a:ln w="19050">
+            <a:solidFill>
+              <a:srgbClr val="CBD5E1"/>
+            </a:solidFill>
+          </a:ln>
+        </p:spPr>
+        <p:style>
+          <a:lnRef idx="1">
+            <a:schemeClr val="accent1"/>
+          </a:lnRef>
+          <a:fillRef idx="3">
+            <a:schemeClr val="accent1"/>
+          </a:fillRef>
+          <a:effectRef idx="2">
+            <a:schemeClr val="accent1"/>
+          </a:effectRef>
+          <a:fontRef idx="minor">
+            <a:schemeClr val="lt1"/>
+          </a:fontRef>
+        </p:style>
+        <p:txBody>
+          <a:bodyPr rtlCol="0" anchor="ctr"/>
+          <a:lstStyle/>
+          <a:p>
+            <a:pPr algn="ctr"/>
+          </a:p>
+        </p:txBody>
+      </p:sp>
+      <p:sp>
+        <p:nvSpPr>
+          <p:cNvPr id="6" name="TextBox 5"/>
+          <p:cNvSpPr txBox="1"/>
+          <p:nvPr/>
+        </p:nvSpPr>
+        <p:spPr>
+          <a:xfrm>
+            <a:off x="6446520" y="2057400"/>
+            <a:ext cx="4754880" cy="3657600"/>
+          </a:xfrm>
+          <a:prstGeom prst="rect">
+            <a:avLst/>
+          </a:prstGeom>
+          <a:noFill/>
+        </p:spPr>
+        <p:txBody>
+          <a:bodyPr wrap="square" lIns="0" tIns="0" rIns="0" bIns="0">
+            <a:spAutoFit/>
+          </a:bodyPr>
+          <a:lstStyle/>
+          <a:p>
+            <a:pPr>
+              <a:spcAft>
+                <a:spcPts val="1200"/>
+              </a:spcAft>
+              <a:defRPr sz="2000" b="1">
+                <a:solidFill>
+                  <a:srgbClr val="B45309"/>
+                </a:solidFill>
+                <a:latin typeface="Arial"/>
+              </a:defRPr>
+            </a:pPr>
+            <a:r>
+              <a:t>Persona 2: Người trẻ độc thân</a:t>
+            </a:r>
+          </a:p>
+          <a:p>
+            <a:pPr>
+              <a:spcAft>
+                <a:spcPts val="800"/>
+              </a:spcAft>
+              <a:defRPr sz="1400">
+                <a:solidFill>
+                  <a:srgbClr val="0F172A"/>
+                </a:solidFill>
+                <a:latin typeface="Arial"/>
+              </a:defRPr>
+            </a:pPr>
+            <a:r>
+              <a:t>Ràng buộc: Giá &lt;= 5.5 tỷ, PN &gt;= 2. Ưu tiên: Giá rẻ, Siêu thị.</a:t>
+            </a:r>
+          </a:p>
+          <a:p>
+            <a:pPr>
+              <a:spcAft>
+                <a:spcPts val="800"/>
+              </a:spcAft>
+              <a:defRPr sz="1400">
+                <a:solidFill>
+                  <a:srgbClr val="0F172A"/>
+                </a:solidFill>
+                <a:latin typeface="Arial"/>
+              </a:defRPr>
+            </a:pPr>
+            <a:r>
+              <a:t>Số căn thỏa mãn lọc: 14 / 37.</a:t>
+            </a:r>
+          </a:p>
+          <a:p>
+            <a:pPr>
+              <a:spcAft>
+                <a:spcPts val="800"/>
+              </a:spcAft>
+              <a:defRPr sz="1400">
+                <a:solidFill>
+                  <a:srgbClr val="0F172A"/>
+                </a:solidFill>
+                <a:latin typeface="Arial"/>
+              </a:defRPr>
+            </a:pPr>
+            <a:r>
+              <a:t>Đề xuất tối ưu nhất: GV_037 (Điểm: 0.6380)</a:t>
+            </a:r>
+          </a:p>
+          <a:p>
+            <a:pPr>
+              <a:spcAft>
+                <a:spcPts val="800"/>
+              </a:spcAft>
+              <a:defRPr sz="1400">
+                <a:solidFill>
+                  <a:srgbClr val="0F172A"/>
+                </a:solidFill>
+                <a:latin typeface="Arial"/>
+              </a:defRPr>
+            </a:pPr>
+            <a:r>
+              <a:t>  - Giá: 2.85 tỷ (Rẻ nhất nhóm lọc) | Diện tích: 26m² | 2 PN - 1 WC.</a:t>
+            </a:r>
+          </a:p>
+          <a:p>
+            <a:pPr>
+              <a:spcAft>
+                <a:spcPts val="800"/>
+              </a:spcAft>
+              <a:defRPr sz="1400">
+                <a:solidFill>
+                  <a:srgbClr val="0F172A"/>
+                </a:solidFill>
+                <a:latin typeface="Arial"/>
+              </a:defRPr>
+            </a:pPr>
+            <a:r>
+              <a:t>  - Khoảng cách tiện ích: Siêu thị (269m), Trục chính Quang Trung (472m).</a:t>
+            </a:r>
+          </a:p>
+          <a:p>
+            <a:pPr>
+              <a:spcAft>
+                <a:spcPts val="800"/>
+              </a:spcAft>
+              <a:defRPr sz="1400">
+                <a:solidFill>
+                  <a:srgbClr val="0F172A"/>
+                </a:solidFill>
+                <a:latin typeface="Arial"/>
+              </a:defRPr>
+            </a:pPr>
+            <a:r>
+              <a:t>  - Đánh giá: Tiết kiệm ngân sách tối đa, dễ dàng di chuyển.</a:t>
+            </a:r>
+          </a:p>
+        </p:txBody>
+      </p:sp>
+    </p:spTree>
+  </p:cSld>
+  <p:clrMapOvr>
+    <a:masterClrMapping/>
+  </p:clrMapOvr>
+</p:sld>
+</file>
+
+<file path=ppt/slides/slide9.xml><?xml version="1.0" encoding="utf-8"?>
+<p:sld xmlns:a="http://schemas.openxmlformats.org/drawingml/2006/main" xmlns:p="http://schemas.openxmlformats.org/presentationml/2006/main" xmlns:r="http://schemas.openxmlformats.org/officeDocument/2006/relationships">
+  <p:cSld>
+    <p:bg>
+      <p:bgPr>
+        <a:solidFill>
+          <a:srgbClr val="F8FAFC"/>
+        </a:solidFill>
+        <a:effectLst/>
+      </p:bgPr>
+    </p:bg>
+    <p:spTree>
+      <p:nvGrpSpPr>
+        <p:cNvPr id="1" name=""/>
+        <p:cNvGrpSpPr/>
+        <p:nvPr/>
+      </p:nvGrpSpPr>
+      <p:grpSpPr/>
+      <p:sp>
+        <p:nvSpPr>
+          <p:cNvPr id="2" name="TextBox 1"/>
+          <p:cNvSpPr txBox="1"/>
+          <p:nvPr/>
+        </p:nvSpPr>
+        <p:spPr>
+          <a:xfrm>
+            <a:off x="731520" y="457200"/>
+            <a:ext cx="10698480" cy="1097280"/>
+          </a:xfrm>
+          <a:prstGeom prst="rect">
+            <a:avLst/>
+          </a:prstGeom>
+          <a:noFill/>
+        </p:spPr>
+        <p:txBody>
+          <a:bodyPr wrap="square" lIns="0" tIns="0" rIns="0" bIns="0">
+            <a:spAutoFit/>
+          </a:bodyPr>
+          <a:lstStyle/>
+          <a:p>
+            <a:pPr>
+              <a:defRPr sz="3600" b="1">
+                <a:solidFill>
+                  <a:srgbClr val="1D4ED8"/>
+                </a:solidFill>
+                <a:latin typeface="Arial"/>
+              </a:defRPr>
+            </a:pPr>
+            <a:r>
+              <a:t>8. Kết quả Sơ khởi - Persona 3 &amp; Kế hoạch</a:t>
             </a:r>
           </a:p>
           <a:p>

</xml_diff>